<commit_message>
feat: implement AI routing approval workflow and update ticket status management
</commit_message>
<xml_diff>
--- a/SupportSenseAI_Client_Presentation.pptx
+++ b/SupportSenseAI_Client_Presentation.pptx
@@ -4,17 +4,20 @@
   <p:sldMasterIdLst>
     <p:sldMasterId id="2147483648" r:id="rId1"/>
   </p:sldMasterIdLst>
+  <p:notesMasterIdLst>
+    <p:notesMasterId r:id="rId10"/>
+  </p:notesMasterIdLst>
   <p:sldIdLst>
-    <p:sldId id="256" r:id="rId7"/>
-    <p:sldId id="257" r:id="rId9"/>
-    <p:sldId id="258" r:id="rId10"/>
-    <p:sldId id="259" r:id="rId11"/>
-    <p:sldId id="260" r:id="rId12"/>
-    <p:sldId id="261" r:id="rId13"/>
-    <p:sldId id="262" r:id="rId14"/>
-    <p:sldId id="263" r:id="rId15"/>
+    <p:sldId id="256" r:id="rId2"/>
+    <p:sldId id="257" r:id="rId3"/>
+    <p:sldId id="258" r:id="rId4"/>
+    <p:sldId id="259" r:id="rId5"/>
+    <p:sldId id="260" r:id="rId6"/>
+    <p:sldId id="261" r:id="rId7"/>
+    <p:sldId id="262" r:id="rId8"/>
+    <p:sldId id="263" r:id="rId9"/>
   </p:sldIdLst>
-  <p:sldSz cx="12191695" cy="6858000" type="screen4x3"/>
+  <p:sldSz cx="12192000" cy="6858000"/>
   <p:notesSz cx="6858000" cy="9144000"/>
   <p:defaultTextStyle>
     <a:defPPr>
@@ -111,11 +114,27 @@
       </a:defRPr>
     </a:lvl9pPr>
   </p:defaultTextStyle>
+  <p:extLst>
+    <p:ext uri="{EFAFB233-063F-42B5-8137-9DF3F51BA10A}">
+      <p15:sldGuideLst xmlns:p15="http://schemas.microsoft.com/office/powerpoint/2012/main">
+        <p15:guide id="1" orient="horz" pos="2160">
+          <p15:clr>
+            <a:srgbClr val="A4A3A4"/>
+          </p15:clr>
+        </p15:guide>
+        <p15:guide id="2" pos="2880">
+          <p15:clr>
+            <a:srgbClr val="A4A3A4"/>
+          </p15:clr>
+        </p15:guide>
+      </p15:sldGuideLst>
+    </p:ext>
+  </p:extLst>
 </p:presentation>
 </file>
 
 <file path=ppt/notesMasters/notesMaster1.xml><?xml version="1.0" encoding="utf-8"?>
-<p:notesMaster xmlns:a="http://schemas.openxmlformats.org/drawingml/2006/main" xmlns:p="http://schemas.openxmlformats.org/presentationml/2006/main" xmlns:r="http://schemas.openxmlformats.org/officeDocument/2006/relationships">
+<p:notesMaster xmlns:a="http://schemas.openxmlformats.org/drawingml/2006/main" xmlns:r="http://schemas.openxmlformats.org/officeDocument/2006/relationships" xmlns:p="http://schemas.openxmlformats.org/presentationml/2006/main">
   <p:cSld>
     <p:bg>
       <p:bgRef idx="1001">
@@ -136,241 +155,16 @@
           <a:chExt cx="0" cy="0"/>
         </a:xfrm>
       </p:grpSpPr>
-      <p:sp>
-        <p:nvSpPr>
-          <p:cNvPr id="2" name="Header Placeholder 1"/>
-          <p:cNvSpPr>
-            <a:spLocks noGrp="1"/>
-          </p:cNvSpPr>
-          <p:nvPr>
-            <p:ph type="hdr" sz="quarter"/>
-          </p:nvPr>
-        </p:nvSpPr>
-        <p:spPr>
-          <a:xfrm>
-            <a:off x="0" y="0"/>
-            <a:ext cx="2971800" cy="457200"/>
-          </a:xfrm>
-          <a:prstGeom prst="rect">
-            <a:avLst/>
-          </a:prstGeom>
-        </p:spPr>
-        <p:txBody>
-          <a:bodyPr vert="horz" lIns="91440" tIns="45720" rIns="91440" bIns="45720" rtlCol="0"/>
-          <a:lstStyle>
-            <a:lvl1pPr algn="l">
-              <a:defRPr sz="1200"/>
-            </a:lvl1pPr>
-          </a:lstStyle>
-          <a:p>
-            <a:endParaRPr lang="en-US"/>
-          </a:p>
-        </p:txBody>
-      </p:sp>
-      <p:sp>
-        <p:nvSpPr>
-          <p:cNvPr id="3" name="Date Placeholder 2"/>
-          <p:cNvSpPr>
-            <a:spLocks noGrp="1"/>
-          </p:cNvSpPr>
-          <p:nvPr>
-            <p:ph type="dt" idx="1"/>
-          </p:nvPr>
-        </p:nvSpPr>
-        <p:spPr>
-          <a:xfrm>
-            <a:off x="3884613" y="0"/>
-            <a:ext cx="2971800" cy="457200"/>
-          </a:xfrm>
-          <a:prstGeom prst="rect">
-            <a:avLst/>
-          </a:prstGeom>
-        </p:spPr>
-        <p:txBody>
-          <a:bodyPr vert="horz" lIns="91440" tIns="45720" rIns="91440" bIns="45720" rtlCol="0"/>
-          <a:lstStyle>
-            <a:lvl1pPr algn="r">
-              <a:defRPr sz="1200"/>
-            </a:lvl1pPr>
-          </a:lstStyle>
-          <a:p>
-            <a:fld id="{0F89C1C7-3DCD-1040-A9CF-14679D8B5DDD}" type="datetimeFigureOut">
-              <a:rPr lang="en-US" smtClean="0"/>
-              <a:t>10/17/16</a:t>
-            </a:fld>
-            <a:endParaRPr lang="en-US"/>
-          </a:p>
-        </p:txBody>
-      </p:sp>
-      <p:sp>
-        <p:nvSpPr>
-          <p:cNvPr id="4" name="Slide Image Placeholder 3"/>
-          <p:cNvSpPr>
-            <a:spLocks noGrp="1" noRot="1" noChangeAspect="1"/>
-          </p:cNvSpPr>
-          <p:nvPr>
-            <p:ph type="sldImg" idx="2"/>
-          </p:nvPr>
-        </p:nvSpPr>
-        <p:spPr>
-          <a:xfrm>
-            <a:off x="1143000" y="685800"/>
-            <a:ext cx="4572000" cy="3429000"/>
-          </a:xfrm>
-          <a:prstGeom prst="rect">
-            <a:avLst/>
-          </a:prstGeom>
-          <a:noFill/>
-          <a:ln w="12700">
-            <a:solidFill>
-              <a:prstClr val="black"/>
-            </a:solidFill>
-          </a:ln>
-        </p:spPr>
-        <p:txBody>
-          <a:bodyPr vert="horz" lIns="91440" tIns="45720" rIns="91440" bIns="45720" rtlCol="0" anchor="ctr"/>
-          <a:lstStyle/>
-          <a:p>
-            <a:endParaRPr lang="en-US"/>
-          </a:p>
-        </p:txBody>
-      </p:sp>
-      <p:sp>
-        <p:nvSpPr>
-          <p:cNvPr id="5" name="Notes Placeholder 4"/>
-          <p:cNvSpPr>
-            <a:spLocks noGrp="1"/>
-          </p:cNvSpPr>
-          <p:nvPr>
-            <p:ph type="body" sz="quarter" idx="3"/>
-          </p:nvPr>
-        </p:nvSpPr>
-        <p:spPr>
-          <a:xfrm>
-            <a:off x="685800" y="4343400"/>
-            <a:ext cx="5486400" cy="4114800"/>
-          </a:xfrm>
-          <a:prstGeom prst="rect">
-            <a:avLst/>
-          </a:prstGeom>
-        </p:spPr>
-        <p:txBody>
-          <a:bodyPr vert="horz" lIns="91440" tIns="45720" rIns="91440" bIns="45720" rtlCol="0"/>
-          <a:lstStyle/>
-          <a:p>
-            <a:pPr lvl="0"/>
-            <a:r>
-              <a:rPr lang="en-US" smtClean="0"/>
-              <a:t>Click to edit Master text styles</a:t>
-            </a:r>
-          </a:p>
-          <a:p>
-            <a:pPr lvl="1"/>
-            <a:r>
-              <a:rPr lang="en-US" smtClean="0"/>
-              <a:t>Second level</a:t>
-            </a:r>
-          </a:p>
-          <a:p>
-            <a:pPr lvl="2"/>
-            <a:r>
-              <a:rPr lang="en-US" smtClean="0"/>
-              <a:t>Third level</a:t>
-            </a:r>
-          </a:p>
-          <a:p>
-            <a:pPr lvl="3"/>
-            <a:r>
-              <a:rPr lang="en-US" smtClean="0"/>
-              <a:t>Fourth level</a:t>
-            </a:r>
-          </a:p>
-          <a:p>
-            <a:pPr lvl="4"/>
-            <a:r>
-              <a:rPr lang="en-US" smtClean="0"/>
-              <a:t>Fifth level</a:t>
-            </a:r>
-            <a:endParaRPr lang="en-US"/>
-          </a:p>
-        </p:txBody>
-      </p:sp>
-      <p:sp>
-        <p:nvSpPr>
-          <p:cNvPr id="6" name="Footer Placeholder 5"/>
-          <p:cNvSpPr>
-            <a:spLocks noGrp="1"/>
-          </p:cNvSpPr>
-          <p:nvPr>
-            <p:ph type="ftr" sz="quarter" idx="4"/>
-          </p:nvPr>
-        </p:nvSpPr>
-        <p:spPr>
-          <a:xfrm>
-            <a:off x="0" y="8685213"/>
-            <a:ext cx="2971800" cy="457200"/>
-          </a:xfrm>
-          <a:prstGeom prst="rect">
-            <a:avLst/>
-          </a:prstGeom>
-        </p:spPr>
-        <p:txBody>
-          <a:bodyPr vert="horz" lIns="91440" tIns="45720" rIns="91440" bIns="45720" rtlCol="0" anchor="b"/>
-          <a:lstStyle>
-            <a:lvl1pPr algn="l">
-              <a:defRPr sz="1200"/>
-            </a:lvl1pPr>
-          </a:lstStyle>
-          <a:p>
-            <a:endParaRPr lang="en-US"/>
-          </a:p>
-        </p:txBody>
-      </p:sp>
-      <p:sp>
-        <p:nvSpPr>
-          <p:cNvPr id="7" name="Slide Number Placeholder 6"/>
-          <p:cNvSpPr>
-            <a:spLocks noGrp="1"/>
-          </p:cNvSpPr>
-          <p:nvPr>
-            <p:ph type="sldNum" sz="quarter" idx="5"/>
-          </p:nvPr>
-        </p:nvSpPr>
-        <p:spPr>
-          <a:xfrm>
-            <a:off x="3884613" y="8685213"/>
-            <a:ext cx="2971800" cy="457200"/>
-          </a:xfrm>
-          <a:prstGeom prst="rect">
-            <a:avLst/>
-          </a:prstGeom>
-        </p:spPr>
-        <p:txBody>
-          <a:bodyPr vert="horz" lIns="91440" tIns="45720" rIns="91440" bIns="45720" rtlCol="0" anchor="b"/>
-          <a:lstStyle>
-            <a:lvl1pPr algn="r">
-              <a:defRPr sz="1200"/>
-            </a:lvl1pPr>
-          </a:lstStyle>
-          <a:p>
-            <a:fld id="{BB5E49A5-4136-284D-997B-48E1D791AD67}" type="slidenum">
-              <a:rPr lang="en-US" smtClean="0"/>
-              <a:t>‹#›</a:t>
-            </a:fld>
-            <a:endParaRPr lang="en-US"/>
-          </a:p>
-        </p:txBody>
-      </p:sp>
     </p:spTree>
     <p:extLst>
       <p:ext uri="{BB962C8B-B14F-4D97-AF65-F5344CB8AC3E}">
-        <p14:creationId xmlns:p14="http://schemas.microsoft.com/office/powerpoint/2010/main" val="2623252185"/>
+        <p14:creationId xmlns:p14="http://schemas.microsoft.com/office/powerpoint/2010/main" val="2834849578"/>
       </p:ext>
     </p:extLst>
   </p:cSld>
   <p:clrMap bg1="lt1" tx1="dk1" bg2="lt2" tx2="dk2" accent1="accent1" accent2="accent2" accent3="accent3" accent4="accent4" accent5="accent5" accent6="accent6" hlink="hlink" folHlink="folHlink"/>
   <p:notesStyle>
-    <a:lvl1pPr marL="0" algn="l" defTabSz="457200" rtl="0" eaLnBrk="1" latinLnBrk="0" hangingPunct="1">
+    <a:lvl1pPr marL="0" algn="l" defTabSz="914400" rtl="0" eaLnBrk="1" latinLnBrk="0" hangingPunct="1">
       <a:defRPr sz="1200" kern="1200">
         <a:solidFill>
           <a:schemeClr val="tx1"/>
@@ -380,7 +174,7 @@
         <a:cs typeface="+mn-cs"/>
       </a:defRPr>
     </a:lvl1pPr>
-    <a:lvl2pPr marL="457200" algn="l" defTabSz="457200" rtl="0" eaLnBrk="1" latinLnBrk="0" hangingPunct="1">
+    <a:lvl2pPr marL="457200" algn="l" defTabSz="914400" rtl="0" eaLnBrk="1" latinLnBrk="0" hangingPunct="1">
       <a:defRPr sz="1200" kern="1200">
         <a:solidFill>
           <a:schemeClr val="tx1"/>
@@ -390,7 +184,7 @@
         <a:cs typeface="+mn-cs"/>
       </a:defRPr>
     </a:lvl2pPr>
-    <a:lvl3pPr marL="914400" algn="l" defTabSz="457200" rtl="0" eaLnBrk="1" latinLnBrk="0" hangingPunct="1">
+    <a:lvl3pPr marL="914400" algn="l" defTabSz="914400" rtl="0" eaLnBrk="1" latinLnBrk="0" hangingPunct="1">
       <a:defRPr sz="1200" kern="1200">
         <a:solidFill>
           <a:schemeClr val="tx1"/>
@@ -400,7 +194,7 @@
         <a:cs typeface="+mn-cs"/>
       </a:defRPr>
     </a:lvl3pPr>
-    <a:lvl4pPr marL="1371600" algn="l" defTabSz="457200" rtl="0" eaLnBrk="1" latinLnBrk="0" hangingPunct="1">
+    <a:lvl4pPr marL="1371600" algn="l" defTabSz="914400" rtl="0" eaLnBrk="1" latinLnBrk="0" hangingPunct="1">
       <a:defRPr sz="1200" kern="1200">
         <a:solidFill>
           <a:schemeClr val="tx1"/>
@@ -410,7 +204,7 @@
         <a:cs typeface="+mn-cs"/>
       </a:defRPr>
     </a:lvl4pPr>
-    <a:lvl5pPr marL="1828800" algn="l" defTabSz="457200" rtl="0" eaLnBrk="1" latinLnBrk="0" hangingPunct="1">
+    <a:lvl5pPr marL="1828800" algn="l" defTabSz="914400" rtl="0" eaLnBrk="1" latinLnBrk="0" hangingPunct="1">
       <a:defRPr sz="1200" kern="1200">
         <a:solidFill>
           <a:schemeClr val="tx1"/>
@@ -420,7 +214,7 @@
         <a:cs typeface="+mn-cs"/>
       </a:defRPr>
     </a:lvl5pPr>
-    <a:lvl6pPr marL="2286000" algn="l" defTabSz="457200" rtl="0" eaLnBrk="1" latinLnBrk="0" hangingPunct="1">
+    <a:lvl6pPr marL="2286000" algn="l" defTabSz="914400" rtl="0" eaLnBrk="1" latinLnBrk="0" hangingPunct="1">
       <a:defRPr sz="1200" kern="1200">
         <a:solidFill>
           <a:schemeClr val="tx1"/>
@@ -430,7 +224,7 @@
         <a:cs typeface="+mn-cs"/>
       </a:defRPr>
     </a:lvl6pPr>
-    <a:lvl7pPr marL="2743200" algn="l" defTabSz="457200" rtl="0" eaLnBrk="1" latinLnBrk="0" hangingPunct="1">
+    <a:lvl7pPr marL="2743200" algn="l" defTabSz="914400" rtl="0" eaLnBrk="1" latinLnBrk="0" hangingPunct="1">
       <a:defRPr sz="1200" kern="1200">
         <a:solidFill>
           <a:schemeClr val="tx1"/>
@@ -440,7 +234,7 @@
         <a:cs typeface="+mn-cs"/>
       </a:defRPr>
     </a:lvl7pPr>
-    <a:lvl8pPr marL="3200400" algn="l" defTabSz="457200" rtl="0" eaLnBrk="1" latinLnBrk="0" hangingPunct="1">
+    <a:lvl8pPr marL="3200400" algn="l" defTabSz="914400" rtl="0" eaLnBrk="1" latinLnBrk="0" hangingPunct="1">
       <a:defRPr sz="1200" kern="1200">
         <a:solidFill>
           <a:schemeClr val="tx1"/>
@@ -450,7 +244,7 @@
         <a:cs typeface="+mn-cs"/>
       </a:defRPr>
     </a:lvl8pPr>
-    <a:lvl9pPr marL="3657600" algn="l" defTabSz="457200" rtl="0" eaLnBrk="1" latinLnBrk="0" hangingPunct="1">
+    <a:lvl9pPr marL="3657600" algn="l" defTabSz="914400" rtl="0" eaLnBrk="1" latinLnBrk="0" hangingPunct="1">
       <a:defRPr sz="1200" kern="1200">
         <a:solidFill>
           <a:schemeClr val="tx1"/>
@@ -465,7 +259,7 @@
 </file>
 
 <file path=ppt/notesSlides/notesSlide1.xml><?xml version="1.0" encoding="utf-8"?>
-<p:notes xmlns:a="http://schemas.openxmlformats.org/drawingml/2006/main" xmlns:p="http://schemas.openxmlformats.org/presentationml/2006/main" xmlns:r="http://schemas.openxmlformats.org/officeDocument/2006/relationships">
+<p:notes xmlns:a="http://schemas.openxmlformats.org/drawingml/2006/main" xmlns:r="http://schemas.openxmlformats.org/officeDocument/2006/relationships" xmlns:p="http://schemas.openxmlformats.org/presentationml/2006/main">
   <p:cSld>
     <p:spTree>
       <p:nvGrpSpPr>
@@ -485,7 +279,7 @@
         <p:nvSpPr>
           <p:cNvPr id="2" name="Slide Image Placeholder 1"/>
           <p:cNvSpPr>
-            <a:spLocks noGrp="1"/>
+            <a:spLocks noGrp="1" noRot="1" noChangeAspect="1"/>
           </p:cNvSpPr>
           <p:nvPr>
             <p:ph type="sldImg" idx="2"/>
@@ -500,7 +294,7 @@
             <a:spLocks noGrp="1"/>
           </p:cNvSpPr>
           <p:nvPr>
-            <p:ph type="body" idx="3" sz="quarter"/>
+            <p:ph type="body" sz="quarter" idx="3"/>
           </p:nvPr>
         </p:nvSpPr>
         <p:spPr/>
@@ -541,7 +335,7 @@
             <a:spLocks noGrp="1"/>
           </p:cNvSpPr>
           <p:nvPr>
-            <p:ph type="sldNum" idx="5" sz="quarter"/>
+            <p:ph type="sldNum" sz="quarter" idx="5"/>
           </p:nvPr>
         </p:nvSpPr>
         <p:spPr/>
@@ -555,7 +349,7 @@
 </file>
 
 <file path=ppt/notesSlides/notesSlide2.xml><?xml version="1.0" encoding="utf-8"?>
-<p:notes xmlns:a="http://schemas.openxmlformats.org/drawingml/2006/main" xmlns:p="http://schemas.openxmlformats.org/presentationml/2006/main" xmlns:r="http://schemas.openxmlformats.org/officeDocument/2006/relationships">
+<p:notes xmlns:a="http://schemas.openxmlformats.org/drawingml/2006/main" xmlns:r="http://schemas.openxmlformats.org/officeDocument/2006/relationships" xmlns:p="http://schemas.openxmlformats.org/presentationml/2006/main">
   <p:cSld>
     <p:spTree>
       <p:nvGrpSpPr>
@@ -575,7 +369,7 @@
         <p:nvSpPr>
           <p:cNvPr id="2" name="Slide Image Placeholder 1"/>
           <p:cNvSpPr>
-            <a:spLocks noGrp="1"/>
+            <a:spLocks noGrp="1" noRot="1" noChangeAspect="1"/>
           </p:cNvSpPr>
           <p:nvPr>
             <p:ph type="sldImg" idx="2"/>
@@ -590,7 +384,7 @@
             <a:spLocks noGrp="1"/>
           </p:cNvSpPr>
           <p:nvPr>
-            <p:ph type="body" idx="3" sz="quarter"/>
+            <p:ph type="body" sz="quarter" idx="3"/>
           </p:nvPr>
         </p:nvSpPr>
         <p:spPr/>
@@ -631,7 +425,7 @@
             <a:spLocks noGrp="1"/>
           </p:cNvSpPr>
           <p:nvPr>
-            <p:ph type="sldNum" idx="5" sz="quarter"/>
+            <p:ph type="sldNum" sz="quarter" idx="5"/>
           </p:nvPr>
         </p:nvSpPr>
         <p:spPr/>
@@ -645,7 +439,7 @@
 </file>
 
 <file path=ppt/notesSlides/notesSlide3.xml><?xml version="1.0" encoding="utf-8"?>
-<p:notes xmlns:a="http://schemas.openxmlformats.org/drawingml/2006/main" xmlns:p="http://schemas.openxmlformats.org/presentationml/2006/main" xmlns:r="http://schemas.openxmlformats.org/officeDocument/2006/relationships">
+<p:notes xmlns:a="http://schemas.openxmlformats.org/drawingml/2006/main" xmlns:r="http://schemas.openxmlformats.org/officeDocument/2006/relationships" xmlns:p="http://schemas.openxmlformats.org/presentationml/2006/main">
   <p:cSld>
     <p:spTree>
       <p:nvGrpSpPr>
@@ -665,7 +459,7 @@
         <p:nvSpPr>
           <p:cNvPr id="2" name="Slide Image Placeholder 1"/>
           <p:cNvSpPr>
-            <a:spLocks noGrp="1"/>
+            <a:spLocks noGrp="1" noRot="1" noChangeAspect="1"/>
           </p:cNvSpPr>
           <p:nvPr>
             <p:ph type="sldImg" idx="2"/>
@@ -680,7 +474,7 @@
             <a:spLocks noGrp="1"/>
           </p:cNvSpPr>
           <p:nvPr>
-            <p:ph type="body" idx="3" sz="quarter"/>
+            <p:ph type="body" sz="quarter" idx="3"/>
           </p:nvPr>
         </p:nvSpPr>
         <p:spPr/>
@@ -721,7 +515,7 @@
             <a:spLocks noGrp="1"/>
           </p:cNvSpPr>
           <p:nvPr>
-            <p:ph type="sldNum" idx="5" sz="quarter"/>
+            <p:ph type="sldNum" sz="quarter" idx="5"/>
           </p:nvPr>
         </p:nvSpPr>
         <p:spPr/>
@@ -735,7 +529,7 @@
 </file>
 
 <file path=ppt/notesSlides/notesSlide4.xml><?xml version="1.0" encoding="utf-8"?>
-<p:notes xmlns:a="http://schemas.openxmlformats.org/drawingml/2006/main" xmlns:p="http://schemas.openxmlformats.org/presentationml/2006/main" xmlns:r="http://schemas.openxmlformats.org/officeDocument/2006/relationships">
+<p:notes xmlns:a="http://schemas.openxmlformats.org/drawingml/2006/main" xmlns:r="http://schemas.openxmlformats.org/officeDocument/2006/relationships" xmlns:p="http://schemas.openxmlformats.org/presentationml/2006/main">
   <p:cSld>
     <p:spTree>
       <p:nvGrpSpPr>
@@ -755,7 +549,7 @@
         <p:nvSpPr>
           <p:cNvPr id="2" name="Slide Image Placeholder 1"/>
           <p:cNvSpPr>
-            <a:spLocks noGrp="1"/>
+            <a:spLocks noGrp="1" noRot="1" noChangeAspect="1"/>
           </p:cNvSpPr>
           <p:nvPr>
             <p:ph type="sldImg" idx="2"/>
@@ -770,7 +564,7 @@
             <a:spLocks noGrp="1"/>
           </p:cNvSpPr>
           <p:nvPr>
-            <p:ph type="body" idx="3" sz="quarter"/>
+            <p:ph type="body" sz="quarter" idx="3"/>
           </p:nvPr>
         </p:nvSpPr>
         <p:spPr/>
@@ -811,7 +605,7 @@
             <a:spLocks noGrp="1"/>
           </p:cNvSpPr>
           <p:nvPr>
-            <p:ph type="sldNum" idx="5" sz="quarter"/>
+            <p:ph type="sldNum" sz="quarter" idx="5"/>
           </p:nvPr>
         </p:nvSpPr>
         <p:spPr/>
@@ -825,7 +619,7 @@
 </file>
 
 <file path=ppt/notesSlides/notesSlide5.xml><?xml version="1.0" encoding="utf-8"?>
-<p:notes xmlns:a="http://schemas.openxmlformats.org/drawingml/2006/main" xmlns:p="http://schemas.openxmlformats.org/presentationml/2006/main" xmlns:r="http://schemas.openxmlformats.org/officeDocument/2006/relationships">
+<p:notes xmlns:a="http://schemas.openxmlformats.org/drawingml/2006/main" xmlns:r="http://schemas.openxmlformats.org/officeDocument/2006/relationships" xmlns:p="http://schemas.openxmlformats.org/presentationml/2006/main">
   <p:cSld>
     <p:spTree>
       <p:nvGrpSpPr>
@@ -845,7 +639,7 @@
         <p:nvSpPr>
           <p:cNvPr id="2" name="Slide Image Placeholder 1"/>
           <p:cNvSpPr>
-            <a:spLocks noGrp="1"/>
+            <a:spLocks noGrp="1" noRot="1" noChangeAspect="1"/>
           </p:cNvSpPr>
           <p:nvPr>
             <p:ph type="sldImg" idx="2"/>
@@ -860,7 +654,7 @@
             <a:spLocks noGrp="1"/>
           </p:cNvSpPr>
           <p:nvPr>
-            <p:ph type="body" idx="3" sz="quarter"/>
+            <p:ph type="body" sz="quarter" idx="3"/>
           </p:nvPr>
         </p:nvSpPr>
         <p:spPr/>
@@ -901,7 +695,7 @@
             <a:spLocks noGrp="1"/>
           </p:cNvSpPr>
           <p:nvPr>
-            <p:ph type="sldNum" idx="5" sz="quarter"/>
+            <p:ph type="sldNum" sz="quarter" idx="5"/>
           </p:nvPr>
         </p:nvSpPr>
         <p:spPr/>
@@ -915,7 +709,7 @@
 </file>
 
 <file path=ppt/notesSlides/notesSlide6.xml><?xml version="1.0" encoding="utf-8"?>
-<p:notes xmlns:a="http://schemas.openxmlformats.org/drawingml/2006/main" xmlns:p="http://schemas.openxmlformats.org/presentationml/2006/main" xmlns:r="http://schemas.openxmlformats.org/officeDocument/2006/relationships">
+<p:notes xmlns:a="http://schemas.openxmlformats.org/drawingml/2006/main" xmlns:r="http://schemas.openxmlformats.org/officeDocument/2006/relationships" xmlns:p="http://schemas.openxmlformats.org/presentationml/2006/main">
   <p:cSld>
     <p:spTree>
       <p:nvGrpSpPr>
@@ -935,7 +729,7 @@
         <p:nvSpPr>
           <p:cNvPr id="2" name="Slide Image Placeholder 1"/>
           <p:cNvSpPr>
-            <a:spLocks noGrp="1"/>
+            <a:spLocks noGrp="1" noRot="1" noChangeAspect="1"/>
           </p:cNvSpPr>
           <p:nvPr>
             <p:ph type="sldImg" idx="2"/>
@@ -950,7 +744,7 @@
             <a:spLocks noGrp="1"/>
           </p:cNvSpPr>
           <p:nvPr>
-            <p:ph type="body" idx="3" sz="quarter"/>
+            <p:ph type="body" sz="quarter" idx="3"/>
           </p:nvPr>
         </p:nvSpPr>
         <p:spPr/>
@@ -991,7 +785,7 @@
             <a:spLocks noGrp="1"/>
           </p:cNvSpPr>
           <p:nvPr>
-            <p:ph type="sldNum" idx="5" sz="quarter"/>
+            <p:ph type="sldNum" sz="quarter" idx="5"/>
           </p:nvPr>
         </p:nvSpPr>
         <p:spPr/>
@@ -1005,7 +799,7 @@
 </file>
 
 <file path=ppt/notesSlides/notesSlide7.xml><?xml version="1.0" encoding="utf-8"?>
-<p:notes xmlns:a="http://schemas.openxmlformats.org/drawingml/2006/main" xmlns:p="http://schemas.openxmlformats.org/presentationml/2006/main" xmlns:r="http://schemas.openxmlformats.org/officeDocument/2006/relationships">
+<p:notes xmlns:a="http://schemas.openxmlformats.org/drawingml/2006/main" xmlns:r="http://schemas.openxmlformats.org/officeDocument/2006/relationships" xmlns:p="http://schemas.openxmlformats.org/presentationml/2006/main">
   <p:cSld>
     <p:spTree>
       <p:nvGrpSpPr>
@@ -1025,7 +819,7 @@
         <p:nvSpPr>
           <p:cNvPr id="2" name="Slide Image Placeholder 1"/>
           <p:cNvSpPr>
-            <a:spLocks noGrp="1"/>
+            <a:spLocks noGrp="1" noRot="1" noChangeAspect="1"/>
           </p:cNvSpPr>
           <p:nvPr>
             <p:ph type="sldImg" idx="2"/>
@@ -1040,7 +834,7 @@
             <a:spLocks noGrp="1"/>
           </p:cNvSpPr>
           <p:nvPr>
-            <p:ph type="body" idx="3" sz="quarter"/>
+            <p:ph type="body" sz="quarter" idx="3"/>
           </p:nvPr>
         </p:nvSpPr>
         <p:spPr/>
@@ -1081,7 +875,7 @@
             <a:spLocks noGrp="1"/>
           </p:cNvSpPr>
           <p:nvPr>
-            <p:ph type="sldNum" idx="5" sz="quarter"/>
+            <p:ph type="sldNum" sz="quarter" idx="5"/>
           </p:nvPr>
         </p:nvSpPr>
         <p:spPr/>
@@ -1095,7 +889,7 @@
 </file>
 
 <file path=ppt/notesSlides/notesSlide8.xml><?xml version="1.0" encoding="utf-8"?>
-<p:notes xmlns:a="http://schemas.openxmlformats.org/drawingml/2006/main" xmlns:p="http://schemas.openxmlformats.org/presentationml/2006/main" xmlns:r="http://schemas.openxmlformats.org/officeDocument/2006/relationships">
+<p:notes xmlns:a="http://schemas.openxmlformats.org/drawingml/2006/main" xmlns:r="http://schemas.openxmlformats.org/officeDocument/2006/relationships" xmlns:p="http://schemas.openxmlformats.org/presentationml/2006/main">
   <p:cSld>
     <p:spTree>
       <p:nvGrpSpPr>
@@ -1115,7 +909,7 @@
         <p:nvSpPr>
           <p:cNvPr id="2" name="Slide Image Placeholder 1"/>
           <p:cNvSpPr>
-            <a:spLocks noGrp="1"/>
+            <a:spLocks noGrp="1" noRot="1" noChangeAspect="1"/>
           </p:cNvSpPr>
           <p:nvPr>
             <p:ph type="sldImg" idx="2"/>
@@ -1130,7 +924,7 @@
             <a:spLocks noGrp="1"/>
           </p:cNvSpPr>
           <p:nvPr>
-            <p:ph type="body" idx="3" sz="quarter"/>
+            <p:ph type="body" sz="quarter" idx="3"/>
           </p:nvPr>
         </p:nvSpPr>
         <p:spPr/>
@@ -1171,7 +965,7 @@
             <a:spLocks noGrp="1"/>
           </p:cNvSpPr>
           <p:nvPr>
-            <p:ph type="sldNum" idx="5" sz="quarter"/>
+            <p:ph type="sldNum" sz="quarter" idx="5"/>
           </p:nvPr>
         </p:nvSpPr>
         <p:spPr/>
@@ -1222,10 +1016,9 @@
           <a:lstStyle/>
           <a:p>
             <a:r>
-              <a:rPr lang="en-US" smtClean="0"/>
+              <a:rPr lang="en-US"/>
               <a:t>Click to edit Master title style</a:t>
             </a:r>
-            <a:endParaRPr lang="en-US"/>
           </a:p>
         </p:txBody>
       </p:sp>
@@ -1341,10 +1134,9 @@
           </a:lstStyle>
           <a:p>
             <a:r>
-              <a:rPr lang="en-US" smtClean="0"/>
+              <a:rPr lang="en-US"/>
               <a:t>Click to edit Master subtitle style</a:t>
             </a:r>
-            <a:endParaRPr lang="en-US"/>
           </a:p>
         </p:txBody>
       </p:sp>
@@ -1365,7 +1157,7 @@
           <a:p>
             <a:fld id="{5BCAD085-E8A6-8845-BD4E-CB4CCA059FC4}" type="datetimeFigureOut">
               <a:rPr lang="en-US" smtClean="0"/>
-              <a:t>1/27/13</a:t>
+              <a:t>10/5/2026</a:t>
             </a:fld>
             <a:endParaRPr lang="en-US"/>
           </a:p>
@@ -1459,10 +1251,9 @@
           <a:lstStyle/>
           <a:p>
             <a:r>
-              <a:rPr lang="en-US" smtClean="0"/>
+              <a:rPr lang="en-US"/>
               <a:t>Click to edit Master title style</a:t>
             </a:r>
-            <a:endParaRPr lang="en-US"/>
           </a:p>
         </p:txBody>
       </p:sp>
@@ -1483,38 +1274,37 @@
           <a:p>
             <a:pPr lvl="0"/>
             <a:r>
-              <a:rPr lang="en-US" smtClean="0"/>
+              <a:rPr lang="en-US"/>
               <a:t>Click to edit Master text styles</a:t>
             </a:r>
           </a:p>
           <a:p>
             <a:pPr lvl="1"/>
             <a:r>
-              <a:rPr lang="en-US" smtClean="0"/>
+              <a:rPr lang="en-US"/>
               <a:t>Second level</a:t>
             </a:r>
           </a:p>
           <a:p>
             <a:pPr lvl="2"/>
             <a:r>
-              <a:rPr lang="en-US" smtClean="0"/>
+              <a:rPr lang="en-US"/>
               <a:t>Third level</a:t>
             </a:r>
           </a:p>
           <a:p>
             <a:pPr lvl="3"/>
             <a:r>
-              <a:rPr lang="en-US" smtClean="0"/>
+              <a:rPr lang="en-US"/>
               <a:t>Fourth level</a:t>
             </a:r>
           </a:p>
           <a:p>
             <a:pPr lvl="4"/>
             <a:r>
-              <a:rPr lang="en-US" smtClean="0"/>
+              <a:rPr lang="en-US"/>
               <a:t>Fifth level</a:t>
             </a:r>
-            <a:endParaRPr lang="en-US"/>
           </a:p>
         </p:txBody>
       </p:sp>
@@ -1535,7 +1325,7 @@
           <a:p>
             <a:fld id="{5BCAD085-E8A6-8845-BD4E-CB4CCA059FC4}" type="datetimeFigureOut">
               <a:rPr lang="en-US" smtClean="0"/>
-              <a:t>1/27/13</a:t>
+              <a:t>10/5/2026</a:t>
             </a:fld>
             <a:endParaRPr lang="en-US"/>
           </a:p>
@@ -1634,10 +1424,9 @@
           <a:lstStyle/>
           <a:p>
             <a:r>
-              <a:rPr lang="en-US" smtClean="0"/>
+              <a:rPr lang="en-US"/>
               <a:t>Click to edit Master title style</a:t>
             </a:r>
-            <a:endParaRPr lang="en-US"/>
           </a:p>
         </p:txBody>
       </p:sp>
@@ -1663,38 +1452,37 @@
           <a:p>
             <a:pPr lvl="0"/>
             <a:r>
-              <a:rPr lang="en-US" smtClean="0"/>
+              <a:rPr lang="en-US"/>
               <a:t>Click to edit Master text styles</a:t>
             </a:r>
           </a:p>
           <a:p>
             <a:pPr lvl="1"/>
             <a:r>
-              <a:rPr lang="en-US" smtClean="0"/>
+              <a:rPr lang="en-US"/>
               <a:t>Second level</a:t>
             </a:r>
           </a:p>
           <a:p>
             <a:pPr lvl="2"/>
             <a:r>
-              <a:rPr lang="en-US" smtClean="0"/>
+              <a:rPr lang="en-US"/>
               <a:t>Third level</a:t>
             </a:r>
           </a:p>
           <a:p>
             <a:pPr lvl="3"/>
             <a:r>
-              <a:rPr lang="en-US" smtClean="0"/>
+              <a:rPr lang="en-US"/>
               <a:t>Fourth level</a:t>
             </a:r>
           </a:p>
           <a:p>
             <a:pPr lvl="4"/>
             <a:r>
-              <a:rPr lang="en-US" smtClean="0"/>
+              <a:rPr lang="en-US"/>
               <a:t>Fifth level</a:t>
             </a:r>
-            <a:endParaRPr lang="en-US"/>
           </a:p>
         </p:txBody>
       </p:sp>
@@ -1715,7 +1503,7 @@
           <a:p>
             <a:fld id="{5BCAD085-E8A6-8845-BD4E-CB4CCA059FC4}" type="datetimeFigureOut">
               <a:rPr lang="en-US" smtClean="0"/>
-              <a:t>1/27/13</a:t>
+              <a:t>10/5/2026</a:t>
             </a:fld>
             <a:endParaRPr lang="en-US"/>
           </a:p>
@@ -1809,10 +1597,9 @@
           <a:lstStyle/>
           <a:p>
             <a:r>
-              <a:rPr lang="en-US" smtClean="0"/>
+              <a:rPr lang="en-US"/>
               <a:t>Click to edit Master title style</a:t>
             </a:r>
-            <a:endParaRPr lang="en-US"/>
           </a:p>
         </p:txBody>
       </p:sp>
@@ -1833,38 +1620,37 @@
           <a:p>
             <a:pPr lvl="0"/>
             <a:r>
-              <a:rPr lang="en-US" smtClean="0"/>
+              <a:rPr lang="en-US"/>
               <a:t>Click to edit Master text styles</a:t>
             </a:r>
           </a:p>
           <a:p>
             <a:pPr lvl="1"/>
             <a:r>
-              <a:rPr lang="en-US" smtClean="0"/>
+              <a:rPr lang="en-US"/>
               <a:t>Second level</a:t>
             </a:r>
           </a:p>
           <a:p>
             <a:pPr lvl="2"/>
             <a:r>
-              <a:rPr lang="en-US" smtClean="0"/>
+              <a:rPr lang="en-US"/>
               <a:t>Third level</a:t>
             </a:r>
           </a:p>
           <a:p>
             <a:pPr lvl="3"/>
             <a:r>
-              <a:rPr lang="en-US" smtClean="0"/>
+              <a:rPr lang="en-US"/>
               <a:t>Fourth level</a:t>
             </a:r>
           </a:p>
           <a:p>
             <a:pPr lvl="4"/>
             <a:r>
-              <a:rPr lang="en-US" smtClean="0"/>
+              <a:rPr lang="en-US"/>
               <a:t>Fifth level</a:t>
             </a:r>
-            <a:endParaRPr lang="en-US"/>
           </a:p>
         </p:txBody>
       </p:sp>
@@ -1885,7 +1671,7 @@
           <a:p>
             <a:fld id="{5BCAD085-E8A6-8845-BD4E-CB4CCA059FC4}" type="datetimeFigureOut">
               <a:rPr lang="en-US" smtClean="0"/>
-              <a:t>1/27/13</a:t>
+              <a:t>10/5/2026</a:t>
             </a:fld>
             <a:endParaRPr lang="en-US"/>
           </a:p>
@@ -1988,10 +1774,9 @@
           </a:lstStyle>
           <a:p>
             <a:r>
-              <a:rPr lang="en-US" smtClean="0"/>
+              <a:rPr lang="en-US"/>
               <a:t>Click to edit Master title style</a:t>
             </a:r>
-            <a:endParaRPr lang="en-US"/>
           </a:p>
         </p:txBody>
       </p:sp>
@@ -2108,7 +1893,7 @@
           <a:p>
             <a:pPr lvl="0"/>
             <a:r>
-              <a:rPr lang="en-US" smtClean="0"/>
+              <a:rPr lang="en-US"/>
               <a:t>Click to edit Master text styles</a:t>
             </a:r>
           </a:p>
@@ -2131,7 +1916,7 @@
           <a:p>
             <a:fld id="{5BCAD085-E8A6-8845-BD4E-CB4CCA059FC4}" type="datetimeFigureOut">
               <a:rPr lang="en-US" smtClean="0"/>
-              <a:t>1/27/13</a:t>
+              <a:t>10/5/2026</a:t>
             </a:fld>
             <a:endParaRPr lang="en-US"/>
           </a:p>
@@ -2225,10 +2010,9 @@
           <a:lstStyle/>
           <a:p>
             <a:r>
-              <a:rPr lang="en-US" smtClean="0"/>
+              <a:rPr lang="en-US"/>
               <a:t>Click to edit Master title style</a:t>
             </a:r>
-            <a:endParaRPr lang="en-US"/>
           </a:p>
         </p:txBody>
       </p:sp>
@@ -2282,38 +2066,37 @@
           <a:p>
             <a:pPr lvl="0"/>
             <a:r>
-              <a:rPr lang="en-US" smtClean="0"/>
+              <a:rPr lang="en-US"/>
               <a:t>Click to edit Master text styles</a:t>
             </a:r>
           </a:p>
           <a:p>
             <a:pPr lvl="1"/>
             <a:r>
-              <a:rPr lang="en-US" smtClean="0"/>
+              <a:rPr lang="en-US"/>
               <a:t>Second level</a:t>
             </a:r>
           </a:p>
           <a:p>
             <a:pPr lvl="2"/>
             <a:r>
-              <a:rPr lang="en-US" smtClean="0"/>
+              <a:rPr lang="en-US"/>
               <a:t>Third level</a:t>
             </a:r>
           </a:p>
           <a:p>
             <a:pPr lvl="3"/>
             <a:r>
-              <a:rPr lang="en-US" smtClean="0"/>
+              <a:rPr lang="en-US"/>
               <a:t>Fourth level</a:t>
             </a:r>
           </a:p>
           <a:p>
             <a:pPr lvl="4"/>
             <a:r>
-              <a:rPr lang="en-US" smtClean="0"/>
+              <a:rPr lang="en-US"/>
               <a:t>Fifth level</a:t>
             </a:r>
-            <a:endParaRPr lang="en-US"/>
           </a:p>
         </p:txBody>
       </p:sp>
@@ -2367,38 +2150,37 @@
           <a:p>
             <a:pPr lvl="0"/>
             <a:r>
-              <a:rPr lang="en-US" smtClean="0"/>
+              <a:rPr lang="en-US"/>
               <a:t>Click to edit Master text styles</a:t>
             </a:r>
           </a:p>
           <a:p>
             <a:pPr lvl="1"/>
             <a:r>
-              <a:rPr lang="en-US" smtClean="0"/>
+              <a:rPr lang="en-US"/>
               <a:t>Second level</a:t>
             </a:r>
           </a:p>
           <a:p>
             <a:pPr lvl="2"/>
             <a:r>
-              <a:rPr lang="en-US" smtClean="0"/>
+              <a:rPr lang="en-US"/>
               <a:t>Third level</a:t>
             </a:r>
           </a:p>
           <a:p>
             <a:pPr lvl="3"/>
             <a:r>
-              <a:rPr lang="en-US" smtClean="0"/>
+              <a:rPr lang="en-US"/>
               <a:t>Fourth level</a:t>
             </a:r>
           </a:p>
           <a:p>
             <a:pPr lvl="4"/>
             <a:r>
-              <a:rPr lang="en-US" smtClean="0"/>
+              <a:rPr lang="en-US"/>
               <a:t>Fifth level</a:t>
             </a:r>
-            <a:endParaRPr lang="en-US"/>
           </a:p>
         </p:txBody>
       </p:sp>
@@ -2419,7 +2201,7 @@
           <a:p>
             <a:fld id="{5BCAD085-E8A6-8845-BD4E-CB4CCA059FC4}" type="datetimeFigureOut">
               <a:rPr lang="en-US" smtClean="0"/>
-              <a:t>1/27/13</a:t>
+              <a:t>10/5/2026</a:t>
             </a:fld>
             <a:endParaRPr lang="en-US"/>
           </a:p>
@@ -2517,10 +2299,9 @@
           </a:lstStyle>
           <a:p>
             <a:r>
-              <a:rPr lang="en-US" smtClean="0"/>
+              <a:rPr lang="en-US"/>
               <a:t>Click to edit Master title style</a:t>
             </a:r>
-            <a:endParaRPr lang="en-US"/>
           </a:p>
         </p:txBody>
       </p:sp>
@@ -2583,7 +2364,7 @@
           <a:p>
             <a:pPr lvl="0"/>
             <a:r>
-              <a:rPr lang="en-US" smtClean="0"/>
+              <a:rPr lang="en-US"/>
               <a:t>Click to edit Master text styles</a:t>
             </a:r>
           </a:p>
@@ -2639,38 +2420,37 @@
           <a:p>
             <a:pPr lvl="0"/>
             <a:r>
-              <a:rPr lang="en-US" smtClean="0"/>
+              <a:rPr lang="en-US"/>
               <a:t>Click to edit Master text styles</a:t>
             </a:r>
           </a:p>
           <a:p>
             <a:pPr lvl="1"/>
             <a:r>
-              <a:rPr lang="en-US" smtClean="0"/>
+              <a:rPr lang="en-US"/>
               <a:t>Second level</a:t>
             </a:r>
           </a:p>
           <a:p>
             <a:pPr lvl="2"/>
             <a:r>
-              <a:rPr lang="en-US" smtClean="0"/>
+              <a:rPr lang="en-US"/>
               <a:t>Third level</a:t>
             </a:r>
           </a:p>
           <a:p>
             <a:pPr lvl="3"/>
             <a:r>
-              <a:rPr lang="en-US" smtClean="0"/>
+              <a:rPr lang="en-US"/>
               <a:t>Fourth level</a:t>
             </a:r>
           </a:p>
           <a:p>
             <a:pPr lvl="4"/>
             <a:r>
-              <a:rPr lang="en-US" smtClean="0"/>
+              <a:rPr lang="en-US"/>
               <a:t>Fifth level</a:t>
             </a:r>
-            <a:endParaRPr lang="en-US"/>
           </a:p>
         </p:txBody>
       </p:sp>
@@ -2733,7 +2513,7 @@
           <a:p>
             <a:pPr lvl="0"/>
             <a:r>
-              <a:rPr lang="en-US" smtClean="0"/>
+              <a:rPr lang="en-US"/>
               <a:t>Click to edit Master text styles</a:t>
             </a:r>
           </a:p>
@@ -2789,38 +2569,37 @@
           <a:p>
             <a:pPr lvl="0"/>
             <a:r>
-              <a:rPr lang="en-US" smtClean="0"/>
+              <a:rPr lang="en-US"/>
               <a:t>Click to edit Master text styles</a:t>
             </a:r>
           </a:p>
           <a:p>
             <a:pPr lvl="1"/>
             <a:r>
-              <a:rPr lang="en-US" smtClean="0"/>
+              <a:rPr lang="en-US"/>
               <a:t>Second level</a:t>
             </a:r>
           </a:p>
           <a:p>
             <a:pPr lvl="2"/>
             <a:r>
-              <a:rPr lang="en-US" smtClean="0"/>
+              <a:rPr lang="en-US"/>
               <a:t>Third level</a:t>
             </a:r>
           </a:p>
           <a:p>
             <a:pPr lvl="3"/>
             <a:r>
-              <a:rPr lang="en-US" smtClean="0"/>
+              <a:rPr lang="en-US"/>
               <a:t>Fourth level</a:t>
             </a:r>
           </a:p>
           <a:p>
             <a:pPr lvl="4"/>
             <a:r>
-              <a:rPr lang="en-US" smtClean="0"/>
+              <a:rPr lang="en-US"/>
               <a:t>Fifth level</a:t>
             </a:r>
-            <a:endParaRPr lang="en-US"/>
           </a:p>
         </p:txBody>
       </p:sp>
@@ -2841,7 +2620,7 @@
           <a:p>
             <a:fld id="{5BCAD085-E8A6-8845-BD4E-CB4CCA059FC4}" type="datetimeFigureOut">
               <a:rPr lang="en-US" smtClean="0"/>
-              <a:t>1/27/13</a:t>
+              <a:t>10/5/2026</a:t>
             </a:fld>
             <a:endParaRPr lang="en-US"/>
           </a:p>
@@ -2935,10 +2714,9 @@
           <a:lstStyle/>
           <a:p>
             <a:r>
-              <a:rPr lang="en-US" smtClean="0"/>
+              <a:rPr lang="en-US"/>
               <a:t>Click to edit Master title style</a:t>
             </a:r>
-            <a:endParaRPr lang="en-US"/>
           </a:p>
         </p:txBody>
       </p:sp>
@@ -2959,7 +2737,7 @@
           <a:p>
             <a:fld id="{5BCAD085-E8A6-8845-BD4E-CB4CCA059FC4}" type="datetimeFigureOut">
               <a:rPr lang="en-US" smtClean="0"/>
-              <a:t>1/27/13</a:t>
+              <a:t>10/5/2026</a:t>
             </a:fld>
             <a:endParaRPr lang="en-US"/>
           </a:p>
@@ -3054,7 +2832,7 @@
           <a:p>
             <a:fld id="{5BCAD085-E8A6-8845-BD4E-CB4CCA059FC4}" type="datetimeFigureOut">
               <a:rPr lang="en-US" smtClean="0"/>
-              <a:t>1/27/13</a:t>
+              <a:t>10/5/2026</a:t>
             </a:fld>
             <a:endParaRPr lang="en-US"/>
           </a:p>
@@ -3157,10 +2935,9 @@
           </a:lstStyle>
           <a:p>
             <a:r>
-              <a:rPr lang="en-US" smtClean="0"/>
+              <a:rPr lang="en-US"/>
               <a:t>Click to edit Master title style</a:t>
             </a:r>
-            <a:endParaRPr lang="en-US"/>
           </a:p>
         </p:txBody>
       </p:sp>
@@ -3214,38 +2991,37 @@
           <a:p>
             <a:pPr lvl="0"/>
             <a:r>
-              <a:rPr lang="en-US" smtClean="0"/>
+              <a:rPr lang="en-US"/>
               <a:t>Click to edit Master text styles</a:t>
             </a:r>
           </a:p>
           <a:p>
             <a:pPr lvl="1"/>
             <a:r>
-              <a:rPr lang="en-US" smtClean="0"/>
+              <a:rPr lang="en-US"/>
               <a:t>Second level</a:t>
             </a:r>
           </a:p>
           <a:p>
             <a:pPr lvl="2"/>
             <a:r>
-              <a:rPr lang="en-US" smtClean="0"/>
+              <a:rPr lang="en-US"/>
               <a:t>Third level</a:t>
             </a:r>
           </a:p>
           <a:p>
             <a:pPr lvl="3"/>
             <a:r>
-              <a:rPr lang="en-US" smtClean="0"/>
+              <a:rPr lang="en-US"/>
               <a:t>Fourth level</a:t>
             </a:r>
           </a:p>
           <a:p>
             <a:pPr lvl="4"/>
             <a:r>
-              <a:rPr lang="en-US" smtClean="0"/>
+              <a:rPr lang="en-US"/>
               <a:t>Fifth level</a:t>
             </a:r>
-            <a:endParaRPr lang="en-US"/>
           </a:p>
         </p:txBody>
       </p:sp>
@@ -3308,7 +3084,7 @@
           <a:p>
             <a:pPr lvl="0"/>
             <a:r>
-              <a:rPr lang="en-US" smtClean="0"/>
+              <a:rPr lang="en-US"/>
               <a:t>Click to edit Master text styles</a:t>
             </a:r>
           </a:p>
@@ -3331,7 +3107,7 @@
           <a:p>
             <a:fld id="{5BCAD085-E8A6-8845-BD4E-CB4CCA059FC4}" type="datetimeFigureOut">
               <a:rPr lang="en-US" smtClean="0"/>
-              <a:t>1/27/13</a:t>
+              <a:t>10/5/2026</a:t>
             </a:fld>
             <a:endParaRPr lang="en-US"/>
           </a:p>
@@ -3434,10 +3210,9 @@
           </a:lstStyle>
           <a:p>
             <a:r>
-              <a:rPr lang="en-US" smtClean="0"/>
+              <a:rPr lang="en-US"/>
               <a:t>Click to edit Master title style</a:t>
             </a:r>
-            <a:endParaRPr lang="en-US"/>
           </a:p>
         </p:txBody>
       </p:sp>
@@ -3561,7 +3336,7 @@
           <a:p>
             <a:pPr lvl="0"/>
             <a:r>
-              <a:rPr lang="en-US" smtClean="0"/>
+              <a:rPr lang="en-US"/>
               <a:t>Click to edit Master text styles</a:t>
             </a:r>
           </a:p>
@@ -3584,7 +3359,7 @@
           <a:p>
             <a:fld id="{5BCAD085-E8A6-8845-BD4E-CB4CCA059FC4}" type="datetimeFigureOut">
               <a:rPr lang="en-US" smtClean="0"/>
-              <a:t>1/27/13</a:t>
+              <a:t>10/5/2026</a:t>
             </a:fld>
             <a:endParaRPr lang="en-US"/>
           </a:p>
@@ -3693,10 +3468,9 @@
           <a:lstStyle/>
           <a:p>
             <a:r>
-              <a:rPr lang="en-US" smtClean="0"/>
+              <a:rPr lang="en-US"/>
               <a:t>Click to edit Master title style</a:t>
             </a:r>
-            <a:endParaRPr lang="en-US"/>
           </a:p>
         </p:txBody>
       </p:sp>
@@ -3727,38 +3501,37 @@
           <a:p>
             <a:pPr lvl="0"/>
             <a:r>
-              <a:rPr lang="en-US" smtClean="0"/>
+              <a:rPr lang="en-US"/>
               <a:t>Click to edit Master text styles</a:t>
             </a:r>
           </a:p>
           <a:p>
             <a:pPr lvl="1"/>
             <a:r>
-              <a:rPr lang="en-US" smtClean="0"/>
+              <a:rPr lang="en-US"/>
               <a:t>Second level</a:t>
             </a:r>
           </a:p>
           <a:p>
             <a:pPr lvl="2"/>
             <a:r>
-              <a:rPr lang="en-US" smtClean="0"/>
+              <a:rPr lang="en-US"/>
               <a:t>Third level</a:t>
             </a:r>
           </a:p>
           <a:p>
             <a:pPr lvl="3"/>
             <a:r>
-              <a:rPr lang="en-US" smtClean="0"/>
+              <a:rPr lang="en-US"/>
               <a:t>Fourth level</a:t>
             </a:r>
           </a:p>
           <a:p>
             <a:pPr lvl="4"/>
             <a:r>
-              <a:rPr lang="en-US" smtClean="0"/>
+              <a:rPr lang="en-US"/>
               <a:t>Fifth level</a:t>
             </a:r>
-            <a:endParaRPr lang="en-US"/>
           </a:p>
         </p:txBody>
       </p:sp>
@@ -3797,7 +3570,7 @@
           <a:p>
             <a:fld id="{5BCAD085-E8A6-8845-BD4E-CB4CCA059FC4}" type="datetimeFigureOut">
               <a:rPr lang="en-US" smtClean="0"/>
-              <a:t>1/27/13</a:t>
+              <a:t>10/5/2026</a:t>
             </a:fld>
             <a:endParaRPr lang="en-US"/>
           </a:p>
@@ -4156,7 +3929,7 @@
 </file>
 
 <file path=ppt/slides/slide1.xml><?xml version="1.0" encoding="utf-8"?>
-<p:sld xmlns:a="http://schemas.openxmlformats.org/drawingml/2006/main" xmlns:p="http://schemas.openxmlformats.org/presentationml/2006/main" xmlns:r="http://schemas.openxmlformats.org/officeDocument/2006/relationships">
+<p:sld xmlns:a="http://schemas.openxmlformats.org/drawingml/2006/main" xmlns:r="http://schemas.openxmlformats.org/officeDocument/2006/relationships" xmlns:p="http://schemas.openxmlformats.org/presentationml/2006/main">
   <p:cSld>
     <p:spTree>
       <p:nvGrpSpPr>
@@ -4164,7 +3937,14 @@
         <p:cNvGrpSpPr/>
         <p:nvPr/>
       </p:nvGrpSpPr>
-      <p:grpSpPr/>
+      <p:grpSpPr>
+        <a:xfrm>
+          <a:off x="0" y="0"/>
+          <a:ext cx="0" cy="0"/>
+          <a:chOff x="0" y="0"/>
+          <a:chExt cx="0" cy="0"/>
+        </a:xfrm>
+      </p:grpSpPr>
       <p:sp>
         <p:nvSpPr>
           <p:cNvPr id="2" name="Rectangle 1"/>
@@ -4205,6 +3985,7 @@
           <a:lstStyle/>
           <a:p>
             <a:pPr algn="ctr"/>
+            <a:endParaRPr/>
           </a:p>
         </p:txBody>
       </p:sp>
@@ -4217,7 +3998,7 @@
           <p:nvPr/>
         </p:nvPicPr>
         <p:blipFill>
-          <a:blip r:embed="rId2"/>
+          <a:blip r:embed="rId3"/>
           <a:stretch>
             <a:fillRect/>
           </a:stretch>
@@ -4340,6 +4121,7 @@
           <a:lstStyle/>
           <a:p>
             <a:pPr algn="ctr"/>
+            <a:endParaRPr/>
           </a:p>
         </p:txBody>
       </p:sp>
@@ -4385,6 +4167,7 @@
           <a:lstStyle/>
           <a:p>
             <a:pPr algn="ctr"/>
+            <a:endParaRPr/>
           </a:p>
         </p:txBody>
       </p:sp>
@@ -4515,6 +4298,7 @@
           <a:lstStyle/>
           <a:p>
             <a:pPr algn="ctr"/>
+            <a:endParaRPr/>
           </a:p>
         </p:txBody>
       </p:sp>
@@ -4527,7 +4311,7 @@
         <p:spPr>
           <a:xfrm>
             <a:off x="3721608" y="3182112"/>
-            <a:ext cx="2112264" cy="320040"/>
+            <a:ext cx="2112264" cy="330860"/>
           </a:xfrm>
           <a:prstGeom prst="rect">
             <a:avLst/>
@@ -4549,6 +4333,7 @@
               </a:defRPr>
             </a:pPr>
             <a:r>
+              <a:rPr dirty="0"/>
               <a:t>Yash Sanikop</a:t>
             </a:r>
           </a:p>
@@ -4562,11 +4347,8 @@
               </a:defRPr>
             </a:pPr>
             <a:r>
+              <a:rPr dirty="0"/>
               <a:t>Frontend &amp; AI Lead</a:t>
-            </a:r>
-            <a:br/>
-            <a:r>
-              <a:t>(Intern: Roll No. 23CO76)</a:t>
             </a:r>
           </a:p>
         </p:txBody>
@@ -4649,6 +4431,7 @@
           <a:lstStyle/>
           <a:p>
             <a:pPr algn="ctr"/>
+            <a:endParaRPr/>
           </a:p>
         </p:txBody>
       </p:sp>
@@ -4779,6 +4562,7 @@
           <a:lstStyle/>
           <a:p>
             <a:pPr algn="ctr"/>
+            <a:endParaRPr/>
           </a:p>
         </p:txBody>
       </p:sp>
@@ -4876,7 +4660,7 @@
         <p:spPr>
           <a:xfrm>
             <a:off x="822960" y="6217920"/>
-            <a:ext cx="10515600" cy="365760"/>
+            <a:ext cx="4035079" cy="233782"/>
           </a:xfrm>
           <a:prstGeom prst="rect">
             <a:avLst/>
@@ -4898,7 +4682,16 @@
               </a:defRPr>
             </a:pPr>
             <a:r>
-              <a:t>Persistent Systems Ltd. Internship Program | Student Intern: Yash Sanikop (Roll No. 23CO76) | Industry Mentor: Vishal Bidikar | Guide: Prof. Laxmikant Bordekar</a:t>
+              <a:rPr dirty="0"/>
+              <a:t>Persistent Systems Ltd. Internship Program | Industry Mentor: Vishal </a:t>
+            </a:r>
+            <a:r>
+              <a:rPr dirty="0" err="1"/>
+              <a:t>Bidikar</a:t>
+            </a:r>
+            <a:r>
+              <a:rPr dirty="0"/>
+              <a:t> | </a:t>
             </a:r>
           </a:p>
         </p:txBody>
@@ -4912,7 +4705,7 @@
 </file>
 
 <file path=ppt/slides/slide2.xml><?xml version="1.0" encoding="utf-8"?>
-<p:sld xmlns:a="http://schemas.openxmlformats.org/drawingml/2006/main" xmlns:p="http://schemas.openxmlformats.org/presentationml/2006/main" xmlns:r="http://schemas.openxmlformats.org/officeDocument/2006/relationships">
+<p:sld xmlns:a="http://schemas.openxmlformats.org/drawingml/2006/main" xmlns:r="http://schemas.openxmlformats.org/officeDocument/2006/relationships" xmlns:p="http://schemas.openxmlformats.org/presentationml/2006/main">
   <p:cSld>
     <p:spTree>
       <p:nvGrpSpPr>
@@ -4920,7 +4713,14 @@
         <p:cNvGrpSpPr/>
         <p:nvPr/>
       </p:nvGrpSpPr>
-      <p:grpSpPr/>
+      <p:grpSpPr>
+        <a:xfrm>
+          <a:off x="0" y="0"/>
+          <a:ext cx="0" cy="0"/>
+          <a:chOff x="0" y="0"/>
+          <a:chExt cx="0" cy="0"/>
+        </a:xfrm>
+      </p:grpSpPr>
       <p:sp>
         <p:nvSpPr>
           <p:cNvPr id="2" name="Rectangle 1"/>
@@ -4961,6 +4761,7 @@
           <a:lstStyle/>
           <a:p>
             <a:pPr algn="ctr"/>
+            <a:endParaRPr/>
           </a:p>
         </p:txBody>
       </p:sp>
@@ -5002,7 +4803,7 @@
           </a:fontRef>
         </p:style>
         <p:txBody>
-          <a:bodyPr rtlCol="0" anchor="ctr" wrap="square"/>
+          <a:bodyPr wrap="square" rtlCol="0" anchor="ctr"/>
           <a:lstStyle/>
           <a:p>
             <a:pPr algn="ctr">
@@ -5015,61 +4816,6 @@
             </a:pPr>
             <a:r>
               <a:t>  PROBLEM &amp; PRINCIPLE</a:t>
-            </a:r>
-          </a:p>
-        </p:txBody>
-      </p:sp>
-      <p:sp>
-        <p:nvSpPr>
-          <p:cNvPr id="4" name="Rounded Rectangle 3"/>
-          <p:cNvSpPr/>
-          <p:nvPr/>
-        </p:nvSpPr>
-        <p:spPr>
-          <a:xfrm>
-            <a:off x="7619695" y="365760"/>
-            <a:ext cx="3840480" cy="292608"/>
-          </a:xfrm>
-          <a:prstGeom prst="roundRect">
-            <a:avLst/>
-          </a:prstGeom>
-          <a:solidFill>
-            <a:srgbClr val="FFFFFF"/>
-          </a:solidFill>
-          <a:ln w="19050">
-            <a:solidFill>
-              <a:srgbClr val="0284C7"/>
-            </a:solidFill>
-          </a:ln>
-        </p:spPr>
-        <p:style>
-          <a:lnRef idx="1">
-            <a:schemeClr val="accent1"/>
-          </a:lnRef>
-          <a:fillRef idx="3">
-            <a:schemeClr val="accent1"/>
-          </a:fillRef>
-          <a:effectRef idx="2">
-            <a:schemeClr val="accent1"/>
-          </a:effectRef>
-          <a:fontRef idx="minor">
-            <a:schemeClr val="lt1"/>
-          </a:fontRef>
-        </p:style>
-        <p:txBody>
-          <a:bodyPr rtlCol="0" anchor="ctr" wrap="square"/>
-          <a:lstStyle/>
-          <a:p>
-            <a:pPr algn="ctr">
-              <a:defRPr sz="900" b="1">
-                <a:solidFill>
-                  <a:srgbClr val="0F172A"/>
-                </a:solidFill>
-                <a:latin typeface="Calibri"/>
-              </a:defRPr>
-            </a:pPr>
-            <a:r>
-              <a:t>  🗣️ Rohan Salkar  |  Frontend &amp; UI/UX Lead</a:t>
             </a:r>
           </a:p>
         </p:txBody>
@@ -5186,6 +4932,7 @@
           <a:lstStyle/>
           <a:p>
             <a:pPr algn="ctr"/>
+            <a:endParaRPr/>
           </a:p>
         </p:txBody>
       </p:sp>
@@ -5234,7 +4981,7 @@
         <p:spPr>
           <a:xfrm>
             <a:off x="731520" y="6510528"/>
-            <a:ext cx="8686800" cy="274320"/>
+            <a:ext cx="4692310" cy="233782"/>
           </a:xfrm>
           <a:prstGeom prst="rect">
             <a:avLst/>
@@ -5256,7 +5003,12 @@
               </a:defRPr>
             </a:pPr>
             <a:r>
-              <a:t>SupportSense AI — Developer-to-Developer Client Pitch | Persistent Systems Internship | Yash Sanikop (23CO76)</a:t>
+              <a:rPr dirty="0" err="1"/>
+              <a:t>SupportSense</a:t>
+            </a:r>
+            <a:r>
+              <a:rPr dirty="0"/>
+              <a:t> AI — Developer-to-Developer Client Pitch | Persistent Systems Internship | </a:t>
             </a:r>
           </a:p>
         </p:txBody>
@@ -5303,6 +5055,7 @@
           <a:lstStyle/>
           <a:p>
             <a:pPr algn="ctr"/>
+            <a:endParaRPr/>
           </a:p>
         </p:txBody>
       </p:sp>
@@ -5420,6 +5173,7 @@
           <a:lstStyle/>
           <a:p>
             <a:pPr algn="ctr"/>
+            <a:endParaRPr/>
           </a:p>
         </p:txBody>
       </p:sp>
@@ -5537,6 +5291,7 @@
           <a:lstStyle/>
           <a:p>
             <a:pPr algn="ctr"/>
+            <a:endParaRPr/>
           </a:p>
         </p:txBody>
       </p:sp>
@@ -5654,6 +5409,7 @@
           <a:lstStyle/>
           <a:p>
             <a:pPr algn="ctr"/>
+            <a:endParaRPr/>
           </a:p>
         </p:txBody>
       </p:sp>
@@ -5838,7 +5594,7 @@
 </file>
 
 <file path=ppt/slides/slide3.xml><?xml version="1.0" encoding="utf-8"?>
-<p:sld xmlns:a="http://schemas.openxmlformats.org/drawingml/2006/main" xmlns:p="http://schemas.openxmlformats.org/presentationml/2006/main" xmlns:r="http://schemas.openxmlformats.org/officeDocument/2006/relationships">
+<p:sld xmlns:a="http://schemas.openxmlformats.org/drawingml/2006/main" xmlns:r="http://schemas.openxmlformats.org/officeDocument/2006/relationships" xmlns:p="http://schemas.openxmlformats.org/presentationml/2006/main">
   <p:cSld>
     <p:spTree>
       <p:nvGrpSpPr>
@@ -5846,7 +5602,14 @@
         <p:cNvGrpSpPr/>
         <p:nvPr/>
       </p:nvGrpSpPr>
-      <p:grpSpPr/>
+      <p:grpSpPr>
+        <a:xfrm>
+          <a:off x="0" y="0"/>
+          <a:ext cx="0" cy="0"/>
+          <a:chOff x="0" y="0"/>
+          <a:chExt cx="0" cy="0"/>
+        </a:xfrm>
+      </p:grpSpPr>
       <p:sp>
         <p:nvSpPr>
           <p:cNvPr id="2" name="Rectangle 1"/>
@@ -5887,6 +5650,7 @@
           <a:lstStyle/>
           <a:p>
             <a:pPr algn="ctr"/>
+            <a:endParaRPr/>
           </a:p>
         </p:txBody>
       </p:sp>
@@ -5928,7 +5692,7 @@
           </a:fontRef>
         </p:style>
         <p:txBody>
-          <a:bodyPr rtlCol="0" anchor="ctr" wrap="square"/>
+          <a:bodyPr wrap="square" rtlCol="0" anchor="ctr"/>
           <a:lstStyle/>
           <a:p>
             <a:pPr algn="ctr">
@@ -5947,14 +5711,207 @@
       </p:sp>
       <p:sp>
         <p:nvSpPr>
-          <p:cNvPr id="4" name="Rounded Rectangle 3"/>
+          <p:cNvPr id="5" name="TextBox 4"/>
+          <p:cNvSpPr txBox="1"/>
+          <p:nvPr/>
+        </p:nvSpPr>
+        <p:spPr>
+          <a:xfrm>
+            <a:off x="731520" y="713232"/>
+            <a:ext cx="10728655" cy="502920"/>
+          </a:xfrm>
+          <a:prstGeom prst="rect">
+            <a:avLst/>
+          </a:prstGeom>
+          <a:noFill/>
+        </p:spPr>
+        <p:txBody>
+          <a:bodyPr wrap="square" lIns="0" tIns="0" rIns="0" bIns="0">
+            <a:spAutoFit/>
+          </a:bodyPr>
+          <a:lstStyle/>
+          <a:p>
+            <a:pPr>
+              <a:defRPr sz="2200" b="1">
+                <a:solidFill>
+                  <a:srgbClr val="0F172A"/>
+                </a:solidFill>
+                <a:latin typeface="Calibri"/>
+              </a:defRPr>
+            </a:pPr>
+            <a:r>
+              <a:t>End-to-End Workflow: How SupportSense AI Operates</a:t>
+            </a:r>
+          </a:p>
+        </p:txBody>
+      </p:sp>
+      <p:sp>
+        <p:nvSpPr>
+          <p:cNvPr id="6" name="TextBox 5"/>
+          <p:cNvSpPr txBox="1"/>
+          <p:nvPr/>
+        </p:nvSpPr>
+        <p:spPr>
+          <a:xfrm>
+            <a:off x="731520" y="1225296"/>
+            <a:ext cx="10728655" cy="320040"/>
+          </a:xfrm>
+          <a:prstGeom prst="rect">
+            <a:avLst/>
+          </a:prstGeom>
+          <a:noFill/>
+        </p:spPr>
+        <p:txBody>
+          <a:bodyPr wrap="square" lIns="0" tIns="0" rIns="0" bIns="0">
+            <a:spAutoFit/>
+          </a:bodyPr>
+          <a:lstStyle/>
+          <a:p>
+            <a:pPr>
+              <a:defRPr sz="1150">
+                <a:solidFill>
+                  <a:srgbClr val="64748B"/>
+                </a:solidFill>
+                <a:latin typeface="Calibri"/>
+              </a:defRPr>
+            </a:pPr>
+            <a:r>
+              <a:t>A 4-step human-centric pipeline transforming unstructured requests into resolved tickets.</a:t>
+            </a:r>
+          </a:p>
+        </p:txBody>
+      </p:sp>
+      <p:sp>
+        <p:nvSpPr>
+          <p:cNvPr id="7" name="Rectangle 6"/>
           <p:cNvSpPr/>
           <p:nvPr/>
         </p:nvSpPr>
         <p:spPr>
           <a:xfrm>
-            <a:off x="7619695" y="365760"/>
-            <a:ext cx="3840480" cy="292608"/>
+            <a:off x="731520" y="1572768"/>
+            <a:ext cx="10728655" cy="13716"/>
+          </a:xfrm>
+          <a:prstGeom prst="rect">
+            <a:avLst/>
+          </a:prstGeom>
+          <a:solidFill>
+            <a:srgbClr val="E2E8F0"/>
+          </a:solidFill>
+          <a:ln>
+            <a:noFill/>
+          </a:ln>
+        </p:spPr>
+        <p:style>
+          <a:lnRef idx="1">
+            <a:schemeClr val="accent1"/>
+          </a:lnRef>
+          <a:fillRef idx="3">
+            <a:schemeClr val="accent1"/>
+          </a:fillRef>
+          <a:effectRef idx="2">
+            <a:schemeClr val="accent1"/>
+          </a:effectRef>
+          <a:fontRef idx="minor">
+            <a:schemeClr val="lt1"/>
+          </a:fontRef>
+        </p:style>
+        <p:txBody>
+          <a:bodyPr rtlCol="0" anchor="ctr"/>
+          <a:lstStyle/>
+          <a:p>
+            <a:pPr algn="ctr"/>
+            <a:endParaRPr/>
+          </a:p>
+        </p:txBody>
+      </p:sp>
+      <p:sp>
+        <p:nvSpPr>
+          <p:cNvPr id="8" name="TextBox 7"/>
+          <p:cNvSpPr txBox="1"/>
+          <p:nvPr/>
+        </p:nvSpPr>
+        <p:spPr>
+          <a:xfrm>
+            <a:off x="10241280" y="6510528"/>
+            <a:ext cx="1218895" cy="274320"/>
+          </a:xfrm>
+          <a:prstGeom prst="rect">
+            <a:avLst/>
+          </a:prstGeom>
+          <a:noFill/>
+        </p:spPr>
+        <p:txBody>
+          <a:bodyPr wrap="none">
+            <a:spAutoFit/>
+          </a:bodyPr>
+          <a:lstStyle/>
+          <a:p>
+            <a:pPr algn="r">
+              <a:defRPr sz="1000" b="1">
+                <a:solidFill>
+                  <a:srgbClr val="64748B"/>
+                </a:solidFill>
+                <a:latin typeface="Calibri"/>
+              </a:defRPr>
+            </a:pPr>
+            <a:r>
+              <a:t>03 / 08</a:t>
+            </a:r>
+          </a:p>
+        </p:txBody>
+      </p:sp>
+      <p:sp>
+        <p:nvSpPr>
+          <p:cNvPr id="9" name="TextBox 8"/>
+          <p:cNvSpPr txBox="1"/>
+          <p:nvPr/>
+        </p:nvSpPr>
+        <p:spPr>
+          <a:xfrm>
+            <a:off x="731520" y="6510528"/>
+            <a:ext cx="4692310" cy="233782"/>
+          </a:xfrm>
+          <a:prstGeom prst="rect">
+            <a:avLst/>
+          </a:prstGeom>
+          <a:noFill/>
+        </p:spPr>
+        <p:txBody>
+          <a:bodyPr wrap="none">
+            <a:spAutoFit/>
+          </a:bodyPr>
+          <a:lstStyle/>
+          <a:p>
+            <a:pPr>
+              <a:defRPr sz="919">
+                <a:solidFill>
+                  <a:srgbClr val="64748B"/>
+                </a:solidFill>
+                <a:latin typeface="Calibri"/>
+              </a:defRPr>
+            </a:pPr>
+            <a:r>
+              <a:rPr dirty="0" err="1"/>
+              <a:t>SupportSense</a:t>
+            </a:r>
+            <a:r>
+              <a:rPr dirty="0"/>
+              <a:t> AI — Developer-to-Developer Client Pitch | Persistent Systems Internship | </a:t>
+            </a:r>
+          </a:p>
+        </p:txBody>
+      </p:sp>
+      <p:sp>
+        <p:nvSpPr>
+          <p:cNvPr id="10" name="Rounded Rectangle 9"/>
+          <p:cNvSpPr/>
+          <p:nvPr/>
+        </p:nvSpPr>
+        <p:spPr>
+          <a:xfrm>
+            <a:off x="731520" y="1691640"/>
+            <a:ext cx="2450592" cy="2926080"/>
           </a:xfrm>
           <a:prstGeom prst="roundRect">
             <a:avLst/>
@@ -5983,252 +5940,11 @@
           </a:fontRef>
         </p:style>
         <p:txBody>
-          <a:bodyPr rtlCol="0" anchor="ctr" wrap="square"/>
-          <a:lstStyle/>
-          <a:p>
-            <a:pPr algn="ctr">
-              <a:defRPr sz="900" b="1">
-                <a:solidFill>
-                  <a:srgbClr val="0F172A"/>
-                </a:solidFill>
-                <a:latin typeface="Calibri"/>
-              </a:defRPr>
-            </a:pPr>
-            <a:r>
-              <a:t>  🗣️ Rohan Salkar  |  Frontend &amp; UI/UX Lead</a:t>
-            </a:r>
-          </a:p>
-        </p:txBody>
-      </p:sp>
-      <p:sp>
-        <p:nvSpPr>
-          <p:cNvPr id="5" name="TextBox 4"/>
-          <p:cNvSpPr txBox="1"/>
-          <p:nvPr/>
-        </p:nvSpPr>
-        <p:spPr>
-          <a:xfrm>
-            <a:off x="731520" y="713232"/>
-            <a:ext cx="10728655" cy="502920"/>
-          </a:xfrm>
-          <a:prstGeom prst="rect">
-            <a:avLst/>
-          </a:prstGeom>
-          <a:noFill/>
-        </p:spPr>
-        <p:txBody>
-          <a:bodyPr wrap="square" lIns="0" tIns="0" rIns="0" bIns="0">
-            <a:spAutoFit/>
-          </a:bodyPr>
-          <a:lstStyle/>
-          <a:p>
-            <a:pPr>
-              <a:defRPr sz="2200" b="1">
-                <a:solidFill>
-                  <a:srgbClr val="0F172A"/>
-                </a:solidFill>
-                <a:latin typeface="Calibri"/>
-              </a:defRPr>
-            </a:pPr>
-            <a:r>
-              <a:t>End-to-End Workflow: How SupportSense AI Operates</a:t>
-            </a:r>
-          </a:p>
-        </p:txBody>
-      </p:sp>
-      <p:sp>
-        <p:nvSpPr>
-          <p:cNvPr id="6" name="TextBox 5"/>
-          <p:cNvSpPr txBox="1"/>
-          <p:nvPr/>
-        </p:nvSpPr>
-        <p:spPr>
-          <a:xfrm>
-            <a:off x="731520" y="1225296"/>
-            <a:ext cx="10728655" cy="320040"/>
-          </a:xfrm>
-          <a:prstGeom prst="rect">
-            <a:avLst/>
-          </a:prstGeom>
-          <a:noFill/>
-        </p:spPr>
-        <p:txBody>
-          <a:bodyPr wrap="square" lIns="0" tIns="0" rIns="0" bIns="0">
-            <a:spAutoFit/>
-          </a:bodyPr>
-          <a:lstStyle/>
-          <a:p>
-            <a:pPr>
-              <a:defRPr sz="1150">
-                <a:solidFill>
-                  <a:srgbClr val="64748B"/>
-                </a:solidFill>
-                <a:latin typeface="Calibri"/>
-              </a:defRPr>
-            </a:pPr>
-            <a:r>
-              <a:t>A 4-step human-centric pipeline transforming unstructured requests into resolved tickets.</a:t>
-            </a:r>
-          </a:p>
-        </p:txBody>
-      </p:sp>
-      <p:sp>
-        <p:nvSpPr>
-          <p:cNvPr id="7" name="Rectangle 6"/>
-          <p:cNvSpPr/>
-          <p:nvPr/>
-        </p:nvSpPr>
-        <p:spPr>
-          <a:xfrm>
-            <a:off x="731520" y="1572768"/>
-            <a:ext cx="10728655" cy="13716"/>
-          </a:xfrm>
-          <a:prstGeom prst="rect">
-            <a:avLst/>
-          </a:prstGeom>
-          <a:solidFill>
-            <a:srgbClr val="E2E8F0"/>
-          </a:solidFill>
-          <a:ln>
-            <a:noFill/>
-          </a:ln>
-        </p:spPr>
-        <p:style>
-          <a:lnRef idx="1">
-            <a:schemeClr val="accent1"/>
-          </a:lnRef>
-          <a:fillRef idx="3">
-            <a:schemeClr val="accent1"/>
-          </a:fillRef>
-          <a:effectRef idx="2">
-            <a:schemeClr val="accent1"/>
-          </a:effectRef>
-          <a:fontRef idx="minor">
-            <a:schemeClr val="lt1"/>
-          </a:fontRef>
-        </p:style>
-        <p:txBody>
           <a:bodyPr rtlCol="0" anchor="ctr"/>
           <a:lstStyle/>
           <a:p>
             <a:pPr algn="ctr"/>
-          </a:p>
-        </p:txBody>
-      </p:sp>
-      <p:sp>
-        <p:nvSpPr>
-          <p:cNvPr id="8" name="TextBox 7"/>
-          <p:cNvSpPr txBox="1"/>
-          <p:nvPr/>
-        </p:nvSpPr>
-        <p:spPr>
-          <a:xfrm>
-            <a:off x="10241280" y="6510528"/>
-            <a:ext cx="1218895" cy="274320"/>
-          </a:xfrm>
-          <a:prstGeom prst="rect">
-            <a:avLst/>
-          </a:prstGeom>
-          <a:noFill/>
-        </p:spPr>
-        <p:txBody>
-          <a:bodyPr wrap="none">
-            <a:spAutoFit/>
-          </a:bodyPr>
-          <a:lstStyle/>
-          <a:p>
-            <a:pPr algn="r">
-              <a:defRPr sz="1000" b="1">
-                <a:solidFill>
-                  <a:srgbClr val="64748B"/>
-                </a:solidFill>
-                <a:latin typeface="Calibri"/>
-              </a:defRPr>
-            </a:pPr>
-            <a:r>
-              <a:t>03 / 08</a:t>
-            </a:r>
-          </a:p>
-        </p:txBody>
-      </p:sp>
-      <p:sp>
-        <p:nvSpPr>
-          <p:cNvPr id="9" name="TextBox 8"/>
-          <p:cNvSpPr txBox="1"/>
-          <p:nvPr/>
-        </p:nvSpPr>
-        <p:spPr>
-          <a:xfrm>
-            <a:off x="731520" y="6510528"/>
-            <a:ext cx="8686800" cy="274320"/>
-          </a:xfrm>
-          <a:prstGeom prst="rect">
-            <a:avLst/>
-          </a:prstGeom>
-          <a:noFill/>
-        </p:spPr>
-        <p:txBody>
-          <a:bodyPr wrap="none">
-            <a:spAutoFit/>
-          </a:bodyPr>
-          <a:lstStyle/>
-          <a:p>
-            <a:pPr>
-              <a:defRPr sz="919">
-                <a:solidFill>
-                  <a:srgbClr val="64748B"/>
-                </a:solidFill>
-                <a:latin typeface="Calibri"/>
-              </a:defRPr>
-            </a:pPr>
-            <a:r>
-              <a:t>SupportSense AI — Developer-to-Developer Client Pitch | Persistent Systems Internship | Yash Sanikop (23CO76)</a:t>
-            </a:r>
-          </a:p>
-        </p:txBody>
-      </p:sp>
-      <p:sp>
-        <p:nvSpPr>
-          <p:cNvPr id="10" name="Rounded Rectangle 9"/>
-          <p:cNvSpPr/>
-          <p:nvPr/>
-        </p:nvSpPr>
-        <p:spPr>
-          <a:xfrm>
-            <a:off x="731520" y="1691640"/>
-            <a:ext cx="2450592" cy="2926080"/>
-          </a:xfrm>
-          <a:prstGeom prst="roundRect">
-            <a:avLst/>
-          </a:prstGeom>
-          <a:solidFill>
-            <a:srgbClr val="FFFFFF"/>
-          </a:solidFill>
-          <a:ln w="19050">
-            <a:solidFill>
-              <a:srgbClr val="0284C7"/>
-            </a:solidFill>
-          </a:ln>
-        </p:spPr>
-        <p:style>
-          <a:lnRef idx="1">
-            <a:schemeClr val="accent1"/>
-          </a:lnRef>
-          <a:fillRef idx="3">
-            <a:schemeClr val="accent1"/>
-          </a:fillRef>
-          <a:effectRef idx="2">
-            <a:schemeClr val="accent1"/>
-          </a:effectRef>
-          <a:fontRef idx="minor">
-            <a:schemeClr val="lt1"/>
-          </a:fontRef>
-        </p:style>
-        <p:txBody>
-          <a:bodyPr rtlCol="0" anchor="ctr"/>
-          <a:lstStyle/>
-          <a:p>
-            <a:pPr algn="ctr"/>
+            <a:endParaRPr/>
           </a:p>
         </p:txBody>
       </p:sp>
@@ -6382,6 +6098,7 @@
           <a:lstStyle/>
           <a:p>
             <a:pPr algn="ctr"/>
+            <a:endParaRPr/>
           </a:p>
         </p:txBody>
       </p:sp>
@@ -6535,6 +6252,7 @@
           <a:lstStyle/>
           <a:p>
             <a:pPr algn="ctr"/>
+            <a:endParaRPr/>
           </a:p>
         </p:txBody>
       </p:sp>
@@ -6688,6 +6406,7 @@
           <a:lstStyle/>
           <a:p>
             <a:pPr algn="ctr"/>
+            <a:endParaRPr/>
           </a:p>
         </p:txBody>
       </p:sp>
@@ -6805,6 +6524,7 @@
           <a:lstStyle/>
           <a:p>
             <a:pPr algn="ctr"/>
+            <a:endParaRPr/>
           </a:p>
         </p:txBody>
       </p:sp>
@@ -6939,7 +6659,7 @@
 </file>
 
 <file path=ppt/slides/slide4.xml><?xml version="1.0" encoding="utf-8"?>
-<p:sld xmlns:a="http://schemas.openxmlformats.org/drawingml/2006/main" xmlns:p="http://schemas.openxmlformats.org/presentationml/2006/main" xmlns:r="http://schemas.openxmlformats.org/officeDocument/2006/relationships">
+<p:sld xmlns:a="http://schemas.openxmlformats.org/drawingml/2006/main" xmlns:r="http://schemas.openxmlformats.org/officeDocument/2006/relationships" xmlns:p="http://schemas.openxmlformats.org/presentationml/2006/main">
   <p:cSld>
     <p:spTree>
       <p:nvGrpSpPr>
@@ -6947,7 +6667,14 @@
         <p:cNvGrpSpPr/>
         <p:nvPr/>
       </p:nvGrpSpPr>
-      <p:grpSpPr/>
+      <p:grpSpPr>
+        <a:xfrm>
+          <a:off x="0" y="0"/>
+          <a:ext cx="0" cy="0"/>
+          <a:chOff x="0" y="0"/>
+          <a:chExt cx="0" cy="0"/>
+        </a:xfrm>
+      </p:grpSpPr>
       <p:sp>
         <p:nvSpPr>
           <p:cNvPr id="2" name="Rectangle 1"/>
@@ -6988,6 +6715,7 @@
           <a:lstStyle/>
           <a:p>
             <a:pPr algn="ctr"/>
+            <a:endParaRPr/>
           </a:p>
         </p:txBody>
       </p:sp>
@@ -7029,7 +6757,7 @@
           </a:fontRef>
         </p:style>
         <p:txBody>
-          <a:bodyPr rtlCol="0" anchor="ctr" wrap="square"/>
+          <a:bodyPr wrap="square" rtlCol="0" anchor="ctr"/>
           <a:lstStyle/>
           <a:p>
             <a:pPr algn="ctr">
@@ -7042,61 +6770,6 @@
             </a:pPr>
             <a:r>
               <a:t>  FRONTEND EXPERIENCE</a:t>
-            </a:r>
-          </a:p>
-        </p:txBody>
-      </p:sp>
-      <p:sp>
-        <p:nvSpPr>
-          <p:cNvPr id="4" name="Rounded Rectangle 3"/>
-          <p:cNvSpPr/>
-          <p:nvPr/>
-        </p:nvSpPr>
-        <p:spPr>
-          <a:xfrm>
-            <a:off x="7619695" y="365760"/>
-            <a:ext cx="3840480" cy="292608"/>
-          </a:xfrm>
-          <a:prstGeom prst="roundRect">
-            <a:avLst/>
-          </a:prstGeom>
-          <a:solidFill>
-            <a:srgbClr val="FFFFFF"/>
-          </a:solidFill>
-          <a:ln w="19050">
-            <a:solidFill>
-              <a:srgbClr val="0284C7"/>
-            </a:solidFill>
-          </a:ln>
-        </p:spPr>
-        <p:style>
-          <a:lnRef idx="1">
-            <a:schemeClr val="accent1"/>
-          </a:lnRef>
-          <a:fillRef idx="3">
-            <a:schemeClr val="accent1"/>
-          </a:fillRef>
-          <a:effectRef idx="2">
-            <a:schemeClr val="accent1"/>
-          </a:effectRef>
-          <a:fontRef idx="minor">
-            <a:schemeClr val="lt1"/>
-          </a:fontRef>
-        </p:style>
-        <p:txBody>
-          <a:bodyPr rtlCol="0" anchor="ctr" wrap="square"/>
-          <a:lstStyle/>
-          <a:p>
-            <a:pPr algn="ctr">
-              <a:defRPr sz="900" b="1">
-                <a:solidFill>
-                  <a:srgbClr val="0F172A"/>
-                </a:solidFill>
-                <a:latin typeface="Calibri"/>
-              </a:defRPr>
-            </a:pPr>
-            <a:r>
-              <a:t>  🗣️ Rohan Salkar  |  Frontend &amp; UI/UX Lead</a:t>
             </a:r>
           </a:p>
         </p:txBody>
@@ -7213,6 +6886,7 @@
           <a:lstStyle/>
           <a:p>
             <a:pPr algn="ctr"/>
+            <a:endParaRPr/>
           </a:p>
         </p:txBody>
       </p:sp>
@@ -7261,7 +6935,7 @@
         <p:spPr>
           <a:xfrm>
             <a:off x="731520" y="6510528"/>
-            <a:ext cx="8686800" cy="274320"/>
+            <a:ext cx="4692310" cy="233782"/>
           </a:xfrm>
           <a:prstGeom prst="rect">
             <a:avLst/>
@@ -7283,7 +6957,12 @@
               </a:defRPr>
             </a:pPr>
             <a:r>
-              <a:t>SupportSense AI — Developer-to-Developer Client Pitch | Persistent Systems Internship | Yash Sanikop (23CO76)</a:t>
+              <a:rPr dirty="0" err="1"/>
+              <a:t>SupportSense</a:t>
+            </a:r>
+            <a:r>
+              <a:rPr dirty="0"/>
+              <a:t> AI — Developer-to-Developer Client Pitch | Persistent Systems Internship | </a:t>
             </a:r>
           </a:p>
         </p:txBody>
@@ -7330,6 +7009,7 @@
           <a:lstStyle/>
           <a:p>
             <a:pPr algn="ctr"/>
+            <a:endParaRPr/>
           </a:p>
         </p:txBody>
       </p:sp>
@@ -7572,6 +7252,7 @@
           <a:lstStyle/>
           <a:p>
             <a:pPr algn="ctr"/>
+            <a:endParaRPr/>
           </a:p>
         </p:txBody>
       </p:sp>
@@ -7666,6 +7347,7 @@
           <a:lstStyle/>
           <a:p>
             <a:pPr algn="ctr"/>
+            <a:endParaRPr/>
           </a:p>
         </p:txBody>
       </p:sp>
@@ -7678,7 +7360,7 @@
           <p:nvPr/>
         </p:nvPicPr>
         <p:blipFill>
-          <a:blip r:embed="rId2"/>
+          <a:blip r:embed="rId3"/>
           <a:stretch>
             <a:fillRect/>
           </a:stretch>
@@ -7738,7 +7420,7 @@
 </file>
 
 <file path=ppt/slides/slide5.xml><?xml version="1.0" encoding="utf-8"?>
-<p:sld xmlns:a="http://schemas.openxmlformats.org/drawingml/2006/main" xmlns:p="http://schemas.openxmlformats.org/presentationml/2006/main" xmlns:r="http://schemas.openxmlformats.org/officeDocument/2006/relationships">
+<p:sld xmlns:a="http://schemas.openxmlformats.org/drawingml/2006/main" xmlns:r="http://schemas.openxmlformats.org/officeDocument/2006/relationships" xmlns:p="http://schemas.openxmlformats.org/presentationml/2006/main">
   <p:cSld>
     <p:spTree>
       <p:nvGrpSpPr>
@@ -7746,7 +7428,14 @@
         <p:cNvGrpSpPr/>
         <p:nvPr/>
       </p:nvGrpSpPr>
-      <p:grpSpPr/>
+      <p:grpSpPr>
+        <a:xfrm>
+          <a:off x="0" y="0"/>
+          <a:ext cx="0" cy="0"/>
+          <a:chOff x="0" y="0"/>
+          <a:chExt cx="0" cy="0"/>
+        </a:xfrm>
+      </p:grpSpPr>
       <p:sp>
         <p:nvSpPr>
           <p:cNvPr id="2" name="Rectangle 1"/>
@@ -7787,6 +7476,7 @@
           <a:lstStyle/>
           <a:p>
             <a:pPr algn="ctr"/>
+            <a:endParaRPr/>
           </a:p>
         </p:txBody>
       </p:sp>
@@ -7828,7 +7518,7 @@
           </a:fontRef>
         </p:style>
         <p:txBody>
-          <a:bodyPr rtlCol="0" anchor="ctr" wrap="square"/>
+          <a:bodyPr wrap="square" rtlCol="0" anchor="ctr"/>
           <a:lstStyle/>
           <a:p>
             <a:pPr algn="ctr">
@@ -7847,14 +7537,302 @@
       </p:sp>
       <p:sp>
         <p:nvSpPr>
-          <p:cNvPr id="4" name="Rounded Rectangle 3"/>
+          <p:cNvPr id="5" name="TextBox 4"/>
+          <p:cNvSpPr txBox="1"/>
+          <p:nvPr/>
+        </p:nvSpPr>
+        <p:spPr>
+          <a:xfrm>
+            <a:off x="731520" y="713232"/>
+            <a:ext cx="10728655" cy="502920"/>
+          </a:xfrm>
+          <a:prstGeom prst="rect">
+            <a:avLst/>
+          </a:prstGeom>
+          <a:noFill/>
+        </p:spPr>
+        <p:txBody>
+          <a:bodyPr wrap="square" lIns="0" tIns="0" rIns="0" bIns="0">
+            <a:spAutoFit/>
+          </a:bodyPr>
+          <a:lstStyle/>
+          <a:p>
+            <a:pPr>
+              <a:defRPr sz="2200" b="1">
+                <a:solidFill>
+                  <a:srgbClr val="0F172A"/>
+                </a:solidFill>
+                <a:latin typeface="Calibri"/>
+              </a:defRPr>
+            </a:pPr>
+            <a:r>
+              <a:t>Conversational AI Intake &amp; Real-Time FAQ Deflection</a:t>
+            </a:r>
+          </a:p>
+        </p:txBody>
+      </p:sp>
+      <p:sp>
+        <p:nvSpPr>
+          <p:cNvPr id="6" name="TextBox 5"/>
+          <p:cNvSpPr txBox="1"/>
+          <p:nvPr/>
+        </p:nvSpPr>
+        <p:spPr>
+          <a:xfrm>
+            <a:off x="731520" y="1225296"/>
+            <a:ext cx="10728655" cy="320040"/>
+          </a:xfrm>
+          <a:prstGeom prst="rect">
+            <a:avLst/>
+          </a:prstGeom>
+          <a:noFill/>
+        </p:spPr>
+        <p:txBody>
+          <a:bodyPr wrap="square" lIns="0" tIns="0" rIns="0" bIns="0">
+            <a:spAutoFit/>
+          </a:bodyPr>
+          <a:lstStyle/>
+          <a:p>
+            <a:pPr>
+              <a:defRPr sz="1150">
+                <a:solidFill>
+                  <a:srgbClr val="64748B"/>
+                </a:solidFill>
+                <a:latin typeface="Calibri"/>
+              </a:defRPr>
+            </a:pPr>
+            <a:r>
+              <a:t>Transforming casual chats into formal tickets while deflecting 35% of routine requests.</a:t>
+            </a:r>
+          </a:p>
+        </p:txBody>
+      </p:sp>
+      <p:sp>
+        <p:nvSpPr>
+          <p:cNvPr id="7" name="Rectangle 6"/>
           <p:cNvSpPr/>
           <p:nvPr/>
         </p:nvSpPr>
         <p:spPr>
           <a:xfrm>
-            <a:off x="7619695" y="365760"/>
-            <a:ext cx="3840480" cy="292608"/>
+            <a:off x="731520" y="1572768"/>
+            <a:ext cx="10728655" cy="13716"/>
+          </a:xfrm>
+          <a:prstGeom prst="rect">
+            <a:avLst/>
+          </a:prstGeom>
+          <a:solidFill>
+            <a:srgbClr val="E2E8F0"/>
+          </a:solidFill>
+          <a:ln>
+            <a:noFill/>
+          </a:ln>
+        </p:spPr>
+        <p:style>
+          <a:lnRef idx="1">
+            <a:schemeClr val="accent1"/>
+          </a:lnRef>
+          <a:fillRef idx="3">
+            <a:schemeClr val="accent1"/>
+          </a:fillRef>
+          <a:effectRef idx="2">
+            <a:schemeClr val="accent1"/>
+          </a:effectRef>
+          <a:fontRef idx="minor">
+            <a:schemeClr val="lt1"/>
+          </a:fontRef>
+        </p:style>
+        <p:txBody>
+          <a:bodyPr rtlCol="0" anchor="ctr"/>
+          <a:lstStyle/>
+          <a:p>
+            <a:pPr algn="ctr"/>
+            <a:endParaRPr/>
+          </a:p>
+        </p:txBody>
+      </p:sp>
+      <p:sp>
+        <p:nvSpPr>
+          <p:cNvPr id="8" name="TextBox 7"/>
+          <p:cNvSpPr txBox="1"/>
+          <p:nvPr/>
+        </p:nvSpPr>
+        <p:spPr>
+          <a:xfrm>
+            <a:off x="10241280" y="6510528"/>
+            <a:ext cx="1218895" cy="274320"/>
+          </a:xfrm>
+          <a:prstGeom prst="rect">
+            <a:avLst/>
+          </a:prstGeom>
+          <a:noFill/>
+        </p:spPr>
+        <p:txBody>
+          <a:bodyPr wrap="none">
+            <a:spAutoFit/>
+          </a:bodyPr>
+          <a:lstStyle/>
+          <a:p>
+            <a:pPr algn="r">
+              <a:defRPr sz="1000" b="1">
+                <a:solidFill>
+                  <a:srgbClr val="64748B"/>
+                </a:solidFill>
+                <a:latin typeface="Calibri"/>
+              </a:defRPr>
+            </a:pPr>
+            <a:r>
+              <a:t>05 / 08</a:t>
+            </a:r>
+          </a:p>
+        </p:txBody>
+      </p:sp>
+      <p:sp>
+        <p:nvSpPr>
+          <p:cNvPr id="9" name="TextBox 8"/>
+          <p:cNvSpPr txBox="1"/>
+          <p:nvPr/>
+        </p:nvSpPr>
+        <p:spPr>
+          <a:xfrm>
+            <a:off x="731520" y="6510528"/>
+            <a:ext cx="4692310" cy="233782"/>
+          </a:xfrm>
+          <a:prstGeom prst="rect">
+            <a:avLst/>
+          </a:prstGeom>
+          <a:noFill/>
+        </p:spPr>
+        <p:txBody>
+          <a:bodyPr wrap="none">
+            <a:spAutoFit/>
+          </a:bodyPr>
+          <a:lstStyle/>
+          <a:p>
+            <a:pPr>
+              <a:defRPr sz="919">
+                <a:solidFill>
+                  <a:srgbClr val="64748B"/>
+                </a:solidFill>
+                <a:latin typeface="Calibri"/>
+              </a:defRPr>
+            </a:pPr>
+            <a:r>
+              <a:rPr dirty="0" err="1"/>
+              <a:t>SupportSense</a:t>
+            </a:r>
+            <a:r>
+              <a:rPr dirty="0"/>
+              <a:t> AI — Developer-to-Developer Client Pitch | Persistent Systems Internship | </a:t>
+            </a:r>
+          </a:p>
+        </p:txBody>
+      </p:sp>
+      <p:sp>
+        <p:nvSpPr>
+          <p:cNvPr id="10" name="Rounded Rectangle 9"/>
+          <p:cNvSpPr/>
+          <p:nvPr/>
+        </p:nvSpPr>
+        <p:spPr>
+          <a:xfrm>
+            <a:off x="731520" y="1691640"/>
+            <a:ext cx="5257800" cy="4480560"/>
+          </a:xfrm>
+          <a:prstGeom prst="roundRect">
+            <a:avLst/>
+          </a:prstGeom>
+          <a:solidFill>
+            <a:srgbClr val="FFFFFF"/>
+          </a:solidFill>
+          <a:ln w="12700">
+            <a:solidFill>
+              <a:srgbClr val="FD451B"/>
+            </a:solidFill>
+          </a:ln>
+        </p:spPr>
+        <p:style>
+          <a:lnRef idx="1">
+            <a:schemeClr val="accent1"/>
+          </a:lnRef>
+          <a:fillRef idx="3">
+            <a:schemeClr val="accent1"/>
+          </a:fillRef>
+          <a:effectRef idx="2">
+            <a:schemeClr val="accent1"/>
+          </a:effectRef>
+          <a:fontRef idx="minor">
+            <a:schemeClr val="lt1"/>
+          </a:fontRef>
+        </p:style>
+        <p:txBody>
+          <a:bodyPr rtlCol="0" anchor="ctr"/>
+          <a:lstStyle/>
+          <a:p>
+            <a:pPr algn="ctr"/>
+            <a:endParaRPr/>
+          </a:p>
+        </p:txBody>
+      </p:sp>
+      <p:sp>
+        <p:nvSpPr>
+          <p:cNvPr id="11" name="TextBox 10"/>
+          <p:cNvSpPr txBox="1"/>
+          <p:nvPr/>
+        </p:nvSpPr>
+        <p:spPr>
+          <a:xfrm>
+            <a:off x="932688" y="1856232"/>
+            <a:ext cx="4855464" cy="320040"/>
+          </a:xfrm>
+          <a:prstGeom prst="rect">
+            <a:avLst/>
+          </a:prstGeom>
+          <a:noFill/>
+        </p:spPr>
+        <p:txBody>
+          <a:bodyPr wrap="square" lIns="0" tIns="0" rIns="0" bIns="0">
+            <a:spAutoFit/>
+          </a:bodyPr>
+          <a:lstStyle/>
+          <a:p>
+            <a:pPr>
+              <a:defRPr sz="1200" b="1">
+                <a:solidFill>
+                  <a:srgbClr val="0F172A"/>
+                </a:solidFill>
+                <a:latin typeface="Calibri"/>
+              </a:defRPr>
+            </a:pPr>
+            <a:r>
+              <a:t>1. Conversational AI Concierge Widget</a:t>
+            </a:r>
+          </a:p>
+          <a:p>
+            <a:pPr>
+              <a:defRPr sz="950">
+                <a:solidFill>
+                  <a:srgbClr val="64748B"/>
+                </a:solidFill>
+                <a:latin typeface="Calibri"/>
+              </a:defRPr>
+            </a:pPr>
+            <a:r>
+              <a:t>SSAI-406 Natural language ticket crafter</a:t>
+            </a:r>
+          </a:p>
+        </p:txBody>
+      </p:sp>
+      <p:sp>
+        <p:nvSpPr>
+          <p:cNvPr id="12" name="Rounded Rectangle 11"/>
+          <p:cNvSpPr/>
+          <p:nvPr/>
+        </p:nvSpPr>
+        <p:spPr>
+          <a:xfrm>
+            <a:off x="832103" y="2249424"/>
+            <a:ext cx="5056632" cy="2761488"/>
           </a:xfrm>
           <a:prstGeom prst="roundRect">
             <a:avLst/>
@@ -7883,346 +7861,11 @@
           </a:fontRef>
         </p:style>
         <p:txBody>
-          <a:bodyPr rtlCol="0" anchor="ctr" wrap="square"/>
-          <a:lstStyle/>
-          <a:p>
-            <a:pPr algn="ctr">
-              <a:defRPr sz="900" b="1">
-                <a:solidFill>
-                  <a:srgbClr val="0F172A"/>
-                </a:solidFill>
-                <a:latin typeface="Calibri"/>
-              </a:defRPr>
-            </a:pPr>
-            <a:r>
-              <a:t>  🗣️ Yash Sanikop  |  Frontend &amp; AI Lead (23CO76)</a:t>
-            </a:r>
-          </a:p>
-        </p:txBody>
-      </p:sp>
-      <p:sp>
-        <p:nvSpPr>
-          <p:cNvPr id="5" name="TextBox 4"/>
-          <p:cNvSpPr txBox="1"/>
-          <p:nvPr/>
-        </p:nvSpPr>
-        <p:spPr>
-          <a:xfrm>
-            <a:off x="731520" y="713232"/>
-            <a:ext cx="10728655" cy="502920"/>
-          </a:xfrm>
-          <a:prstGeom prst="rect">
-            <a:avLst/>
-          </a:prstGeom>
-          <a:noFill/>
-        </p:spPr>
-        <p:txBody>
-          <a:bodyPr wrap="square" lIns="0" tIns="0" rIns="0" bIns="0">
-            <a:spAutoFit/>
-          </a:bodyPr>
-          <a:lstStyle/>
-          <a:p>
-            <a:pPr>
-              <a:defRPr sz="2200" b="1">
-                <a:solidFill>
-                  <a:srgbClr val="0F172A"/>
-                </a:solidFill>
-                <a:latin typeface="Calibri"/>
-              </a:defRPr>
-            </a:pPr>
-            <a:r>
-              <a:t>Conversational AI Intake &amp; Real-Time FAQ Deflection</a:t>
-            </a:r>
-          </a:p>
-        </p:txBody>
-      </p:sp>
-      <p:sp>
-        <p:nvSpPr>
-          <p:cNvPr id="6" name="TextBox 5"/>
-          <p:cNvSpPr txBox="1"/>
-          <p:nvPr/>
-        </p:nvSpPr>
-        <p:spPr>
-          <a:xfrm>
-            <a:off x="731520" y="1225296"/>
-            <a:ext cx="10728655" cy="320040"/>
-          </a:xfrm>
-          <a:prstGeom prst="rect">
-            <a:avLst/>
-          </a:prstGeom>
-          <a:noFill/>
-        </p:spPr>
-        <p:txBody>
-          <a:bodyPr wrap="square" lIns="0" tIns="0" rIns="0" bIns="0">
-            <a:spAutoFit/>
-          </a:bodyPr>
-          <a:lstStyle/>
-          <a:p>
-            <a:pPr>
-              <a:defRPr sz="1150">
-                <a:solidFill>
-                  <a:srgbClr val="64748B"/>
-                </a:solidFill>
-                <a:latin typeface="Calibri"/>
-              </a:defRPr>
-            </a:pPr>
-            <a:r>
-              <a:t>Transforming casual chats into formal tickets while deflecting 35% of routine requests.</a:t>
-            </a:r>
-          </a:p>
-        </p:txBody>
-      </p:sp>
-      <p:sp>
-        <p:nvSpPr>
-          <p:cNvPr id="7" name="Rectangle 6"/>
-          <p:cNvSpPr/>
-          <p:nvPr/>
-        </p:nvSpPr>
-        <p:spPr>
-          <a:xfrm>
-            <a:off x="731520" y="1572768"/>
-            <a:ext cx="10728655" cy="13716"/>
-          </a:xfrm>
-          <a:prstGeom prst="rect">
-            <a:avLst/>
-          </a:prstGeom>
-          <a:solidFill>
-            <a:srgbClr val="E2E8F0"/>
-          </a:solidFill>
-          <a:ln>
-            <a:noFill/>
-          </a:ln>
-        </p:spPr>
-        <p:style>
-          <a:lnRef idx="1">
-            <a:schemeClr val="accent1"/>
-          </a:lnRef>
-          <a:fillRef idx="3">
-            <a:schemeClr val="accent1"/>
-          </a:fillRef>
-          <a:effectRef idx="2">
-            <a:schemeClr val="accent1"/>
-          </a:effectRef>
-          <a:fontRef idx="minor">
-            <a:schemeClr val="lt1"/>
-          </a:fontRef>
-        </p:style>
-        <p:txBody>
           <a:bodyPr rtlCol="0" anchor="ctr"/>
           <a:lstStyle/>
           <a:p>
             <a:pPr algn="ctr"/>
-          </a:p>
-        </p:txBody>
-      </p:sp>
-      <p:sp>
-        <p:nvSpPr>
-          <p:cNvPr id="8" name="TextBox 7"/>
-          <p:cNvSpPr txBox="1"/>
-          <p:nvPr/>
-        </p:nvSpPr>
-        <p:spPr>
-          <a:xfrm>
-            <a:off x="10241280" y="6510528"/>
-            <a:ext cx="1218895" cy="274320"/>
-          </a:xfrm>
-          <a:prstGeom prst="rect">
-            <a:avLst/>
-          </a:prstGeom>
-          <a:noFill/>
-        </p:spPr>
-        <p:txBody>
-          <a:bodyPr wrap="none">
-            <a:spAutoFit/>
-          </a:bodyPr>
-          <a:lstStyle/>
-          <a:p>
-            <a:pPr algn="r">
-              <a:defRPr sz="1000" b="1">
-                <a:solidFill>
-                  <a:srgbClr val="64748B"/>
-                </a:solidFill>
-                <a:latin typeface="Calibri"/>
-              </a:defRPr>
-            </a:pPr>
-            <a:r>
-              <a:t>05 / 08</a:t>
-            </a:r>
-          </a:p>
-        </p:txBody>
-      </p:sp>
-      <p:sp>
-        <p:nvSpPr>
-          <p:cNvPr id="9" name="TextBox 8"/>
-          <p:cNvSpPr txBox="1"/>
-          <p:nvPr/>
-        </p:nvSpPr>
-        <p:spPr>
-          <a:xfrm>
-            <a:off x="731520" y="6510528"/>
-            <a:ext cx="8686800" cy="274320"/>
-          </a:xfrm>
-          <a:prstGeom prst="rect">
-            <a:avLst/>
-          </a:prstGeom>
-          <a:noFill/>
-        </p:spPr>
-        <p:txBody>
-          <a:bodyPr wrap="none">
-            <a:spAutoFit/>
-          </a:bodyPr>
-          <a:lstStyle/>
-          <a:p>
-            <a:pPr>
-              <a:defRPr sz="919">
-                <a:solidFill>
-                  <a:srgbClr val="64748B"/>
-                </a:solidFill>
-                <a:latin typeface="Calibri"/>
-              </a:defRPr>
-            </a:pPr>
-            <a:r>
-              <a:t>SupportSense AI — Developer-to-Developer Client Pitch | Persistent Systems Internship | Yash Sanikop (23CO76)</a:t>
-            </a:r>
-          </a:p>
-        </p:txBody>
-      </p:sp>
-      <p:sp>
-        <p:nvSpPr>
-          <p:cNvPr id="10" name="Rounded Rectangle 9"/>
-          <p:cNvSpPr/>
-          <p:nvPr/>
-        </p:nvSpPr>
-        <p:spPr>
-          <a:xfrm>
-            <a:off x="731520" y="1691640"/>
-            <a:ext cx="5257800" cy="4480560"/>
-          </a:xfrm>
-          <a:prstGeom prst="roundRect">
-            <a:avLst/>
-          </a:prstGeom>
-          <a:solidFill>
-            <a:srgbClr val="FFFFFF"/>
-          </a:solidFill>
-          <a:ln w="12700">
-            <a:solidFill>
-              <a:srgbClr val="FD451B"/>
-            </a:solidFill>
-          </a:ln>
-        </p:spPr>
-        <p:style>
-          <a:lnRef idx="1">
-            <a:schemeClr val="accent1"/>
-          </a:lnRef>
-          <a:fillRef idx="3">
-            <a:schemeClr val="accent1"/>
-          </a:fillRef>
-          <a:effectRef idx="2">
-            <a:schemeClr val="accent1"/>
-          </a:effectRef>
-          <a:fontRef idx="minor">
-            <a:schemeClr val="lt1"/>
-          </a:fontRef>
-        </p:style>
-        <p:txBody>
-          <a:bodyPr rtlCol="0" anchor="ctr"/>
-          <a:lstStyle/>
-          <a:p>
-            <a:pPr algn="ctr"/>
-          </a:p>
-        </p:txBody>
-      </p:sp>
-      <p:sp>
-        <p:nvSpPr>
-          <p:cNvPr id="11" name="TextBox 10"/>
-          <p:cNvSpPr txBox="1"/>
-          <p:nvPr/>
-        </p:nvSpPr>
-        <p:spPr>
-          <a:xfrm>
-            <a:off x="932688" y="1856232"/>
-            <a:ext cx="4855464" cy="320040"/>
-          </a:xfrm>
-          <a:prstGeom prst="rect">
-            <a:avLst/>
-          </a:prstGeom>
-          <a:noFill/>
-        </p:spPr>
-        <p:txBody>
-          <a:bodyPr wrap="square" lIns="0" tIns="0" rIns="0" bIns="0">
-            <a:spAutoFit/>
-          </a:bodyPr>
-          <a:lstStyle/>
-          <a:p>
-            <a:pPr>
-              <a:defRPr sz="1200" b="1">
-                <a:solidFill>
-                  <a:srgbClr val="0F172A"/>
-                </a:solidFill>
-                <a:latin typeface="Calibri"/>
-              </a:defRPr>
-            </a:pPr>
-            <a:r>
-              <a:t>1. Conversational AI Concierge Widget</a:t>
-            </a:r>
-          </a:p>
-          <a:p>
-            <a:pPr>
-              <a:defRPr sz="950">
-                <a:solidFill>
-                  <a:srgbClr val="64748B"/>
-                </a:solidFill>
-                <a:latin typeface="Calibri"/>
-              </a:defRPr>
-            </a:pPr>
-            <a:r>
-              <a:t>SSAI-406 Natural language ticket crafter</a:t>
-            </a:r>
-          </a:p>
-        </p:txBody>
-      </p:sp>
-      <p:sp>
-        <p:nvSpPr>
-          <p:cNvPr id="12" name="Rounded Rectangle 11"/>
-          <p:cNvSpPr/>
-          <p:nvPr/>
-        </p:nvSpPr>
-        <p:spPr>
-          <a:xfrm>
-            <a:off x="832103" y="2249424"/>
-            <a:ext cx="5056632" cy="2761488"/>
-          </a:xfrm>
-          <a:prstGeom prst="roundRect">
-            <a:avLst/>
-          </a:prstGeom>
-          <a:solidFill>
-            <a:srgbClr val="FFFFFF"/>
-          </a:solidFill>
-          <a:ln w="19050">
-            <a:solidFill>
-              <a:srgbClr val="FD451B"/>
-            </a:solidFill>
-          </a:ln>
-        </p:spPr>
-        <p:style>
-          <a:lnRef idx="1">
-            <a:schemeClr val="accent1"/>
-          </a:lnRef>
-          <a:fillRef idx="3">
-            <a:schemeClr val="accent1"/>
-          </a:fillRef>
-          <a:effectRef idx="2">
-            <a:schemeClr val="accent1"/>
-          </a:effectRef>
-          <a:fontRef idx="minor">
-            <a:schemeClr val="lt1"/>
-          </a:fontRef>
-        </p:style>
-        <p:txBody>
-          <a:bodyPr rtlCol="0" anchor="ctr"/>
-          <a:lstStyle/>
-          <a:p>
-            <a:pPr algn="ctr"/>
+            <a:endParaRPr/>
           </a:p>
         </p:txBody>
       </p:sp>
@@ -8235,7 +7878,7 @@
           <p:nvPr/>
         </p:nvPicPr>
         <p:blipFill>
-          <a:blip r:embed="rId2"/>
+          <a:blip r:embed="rId3"/>
           <a:stretch>
             <a:fillRect/>
           </a:stretch>
@@ -8401,6 +8044,7 @@
           <a:lstStyle/>
           <a:p>
             <a:pPr algn="ctr"/>
+            <a:endParaRPr/>
           </a:p>
         </p:txBody>
       </p:sp>
@@ -8495,6 +8139,7 @@
           <a:lstStyle/>
           <a:p>
             <a:pPr algn="ctr"/>
+            <a:endParaRPr/>
           </a:p>
         </p:txBody>
       </p:sp>
@@ -8507,7 +8152,7 @@
           <p:nvPr/>
         </p:nvPicPr>
         <p:blipFill>
-          <a:blip r:embed="rId3"/>
+          <a:blip r:embed="rId4"/>
           <a:stretch>
             <a:fillRect/>
           </a:stretch>
@@ -8640,7 +8285,7 @@
 </file>
 
 <file path=ppt/slides/slide6.xml><?xml version="1.0" encoding="utf-8"?>
-<p:sld xmlns:a="http://schemas.openxmlformats.org/drawingml/2006/main" xmlns:p="http://schemas.openxmlformats.org/presentationml/2006/main" xmlns:r="http://schemas.openxmlformats.org/officeDocument/2006/relationships">
+<p:sld xmlns:a="http://schemas.openxmlformats.org/drawingml/2006/main" xmlns:r="http://schemas.openxmlformats.org/officeDocument/2006/relationships" xmlns:p="http://schemas.openxmlformats.org/presentationml/2006/main">
   <p:cSld>
     <p:spTree>
       <p:nvGrpSpPr>
@@ -8648,7 +8293,14 @@
         <p:cNvGrpSpPr/>
         <p:nvPr/>
       </p:nvGrpSpPr>
-      <p:grpSpPr/>
+      <p:grpSpPr>
+        <a:xfrm>
+          <a:off x="0" y="0"/>
+          <a:ext cx="0" cy="0"/>
+          <a:chOff x="0" y="0"/>
+          <a:chExt cx="0" cy="0"/>
+        </a:xfrm>
+      </p:grpSpPr>
       <p:sp>
         <p:nvSpPr>
           <p:cNvPr id="2" name="Rectangle 1"/>
@@ -8689,6 +8341,7 @@
           <a:lstStyle/>
           <a:p>
             <a:pPr algn="ctr"/>
+            <a:endParaRPr/>
           </a:p>
         </p:txBody>
       </p:sp>
@@ -8730,7 +8383,7 @@
           </a:fontRef>
         </p:style>
         <p:txBody>
-          <a:bodyPr rtlCol="0" anchor="ctr" wrap="square"/>
+          <a:bodyPr wrap="square" rtlCol="0" anchor="ctr"/>
           <a:lstStyle/>
           <a:p>
             <a:pPr algn="ctr">
@@ -8743,61 +8396,6 @@
             </a:pPr>
             <a:r>
               <a:t>  BACKEND &amp; DATABASE</a:t>
-            </a:r>
-          </a:p>
-        </p:txBody>
-      </p:sp>
-      <p:sp>
-        <p:nvSpPr>
-          <p:cNvPr id="4" name="Rounded Rectangle 3"/>
-          <p:cNvSpPr/>
-          <p:nvPr/>
-        </p:nvSpPr>
-        <p:spPr>
-          <a:xfrm>
-            <a:off x="7619695" y="365760"/>
-            <a:ext cx="3840480" cy="292608"/>
-          </a:xfrm>
-          <a:prstGeom prst="roundRect">
-            <a:avLst/>
-          </a:prstGeom>
-          <a:solidFill>
-            <a:srgbClr val="FFFFFF"/>
-          </a:solidFill>
-          <a:ln w="19050">
-            <a:solidFill>
-              <a:srgbClr val="059669"/>
-            </a:solidFill>
-          </a:ln>
-        </p:spPr>
-        <p:style>
-          <a:lnRef idx="1">
-            <a:schemeClr val="accent1"/>
-          </a:lnRef>
-          <a:fillRef idx="3">
-            <a:schemeClr val="accent1"/>
-          </a:fillRef>
-          <a:effectRef idx="2">
-            <a:schemeClr val="accent1"/>
-          </a:effectRef>
-          <a:fontRef idx="minor">
-            <a:schemeClr val="lt1"/>
-          </a:fontRef>
-        </p:style>
-        <p:txBody>
-          <a:bodyPr rtlCol="0" anchor="ctr" wrap="square"/>
-          <a:lstStyle/>
-          <a:p>
-            <a:pPr algn="ctr">
-              <a:defRPr sz="900" b="1">
-                <a:solidFill>
-                  <a:srgbClr val="0F172A"/>
-                </a:solidFill>
-                <a:latin typeface="Calibri"/>
-              </a:defRPr>
-            </a:pPr>
-            <a:r>
-              <a:t>  🗣️ Shrujan Mitbavkar  |  Backend &amp; Database Lead</a:t>
             </a:r>
           </a:p>
         </p:txBody>
@@ -8914,6 +8512,7 @@
           <a:lstStyle/>
           <a:p>
             <a:pPr algn="ctr"/>
+            <a:endParaRPr/>
           </a:p>
         </p:txBody>
       </p:sp>
@@ -8962,7 +8561,7 @@
         <p:spPr>
           <a:xfrm>
             <a:off x="731520" y="6510528"/>
-            <a:ext cx="8686800" cy="274320"/>
+            <a:ext cx="4692310" cy="233782"/>
           </a:xfrm>
           <a:prstGeom prst="rect">
             <a:avLst/>
@@ -8984,7 +8583,12 @@
               </a:defRPr>
             </a:pPr>
             <a:r>
-              <a:t>SupportSense AI — Developer-to-Developer Client Pitch | Persistent Systems Internship | Yash Sanikop (23CO76)</a:t>
+              <a:rPr dirty="0" err="1"/>
+              <a:t>SupportSense</a:t>
+            </a:r>
+            <a:r>
+              <a:rPr dirty="0"/>
+              <a:t> AI — Developer-to-Developer Client Pitch | Persistent Systems Internship | </a:t>
             </a:r>
           </a:p>
         </p:txBody>
@@ -9031,6 +8635,7 @@
           <a:lstStyle/>
           <a:p>
             <a:pPr algn="ctr"/>
+            <a:endParaRPr/>
           </a:p>
         </p:txBody>
       </p:sp>
@@ -9273,6 +8878,7 @@
           <a:lstStyle/>
           <a:p>
             <a:pPr algn="ctr"/>
+            <a:endParaRPr/>
           </a:p>
         </p:txBody>
       </p:sp>
@@ -9367,6 +8973,7 @@
           <a:lstStyle/>
           <a:p>
             <a:pPr algn="ctr"/>
+            <a:endParaRPr/>
           </a:p>
         </p:txBody>
       </p:sp>
@@ -9379,7 +8986,7 @@
           <p:nvPr/>
         </p:nvPicPr>
         <p:blipFill>
-          <a:blip r:embed="rId2"/>
+          <a:blip r:embed="rId3"/>
           <a:stretch>
             <a:fillRect/>
           </a:stretch>
@@ -9439,7 +9046,7 @@
 </file>
 
 <file path=ppt/slides/slide7.xml><?xml version="1.0" encoding="utf-8"?>
-<p:sld xmlns:a="http://schemas.openxmlformats.org/drawingml/2006/main" xmlns:p="http://schemas.openxmlformats.org/presentationml/2006/main" xmlns:r="http://schemas.openxmlformats.org/officeDocument/2006/relationships">
+<p:sld xmlns:a="http://schemas.openxmlformats.org/drawingml/2006/main" xmlns:r="http://schemas.openxmlformats.org/officeDocument/2006/relationships" xmlns:p="http://schemas.openxmlformats.org/presentationml/2006/main">
   <p:cSld>
     <p:spTree>
       <p:nvGrpSpPr>
@@ -9447,7 +9054,14 @@
         <p:cNvGrpSpPr/>
         <p:nvPr/>
       </p:nvGrpSpPr>
-      <p:grpSpPr/>
+      <p:grpSpPr>
+        <a:xfrm>
+          <a:off x="0" y="0"/>
+          <a:ext cx="0" cy="0"/>
+          <a:chOff x="0" y="0"/>
+          <a:chExt cx="0" cy="0"/>
+        </a:xfrm>
+      </p:grpSpPr>
       <p:sp>
         <p:nvSpPr>
           <p:cNvPr id="2" name="Rectangle 1"/>
@@ -9488,6 +9102,7 @@
           <a:lstStyle/>
           <a:p>
             <a:pPr algn="ctr"/>
+            <a:endParaRPr/>
           </a:p>
         </p:txBody>
       </p:sp>
@@ -9529,7 +9144,7 @@
           </a:fontRef>
         </p:style>
         <p:txBody>
-          <a:bodyPr rtlCol="0" anchor="ctr" wrap="square"/>
+          <a:bodyPr wrap="square" rtlCol="0" anchor="ctr"/>
           <a:lstStyle/>
           <a:p>
             <a:pPr algn="ctr">
@@ -9542,61 +9157,6 @@
             </a:pPr>
             <a:r>
               <a:t>  AI ENGINE, DEVOPS &amp; SECURITY</a:t>
-            </a:r>
-          </a:p>
-        </p:txBody>
-      </p:sp>
-      <p:sp>
-        <p:nvSpPr>
-          <p:cNvPr id="4" name="Rounded Rectangle 3"/>
-          <p:cNvSpPr/>
-          <p:nvPr/>
-        </p:nvSpPr>
-        <p:spPr>
-          <a:xfrm>
-            <a:off x="7619695" y="365760"/>
-            <a:ext cx="3840480" cy="292608"/>
-          </a:xfrm>
-          <a:prstGeom prst="roundRect">
-            <a:avLst/>
-          </a:prstGeom>
-          <a:solidFill>
-            <a:srgbClr val="FFFFFF"/>
-          </a:solidFill>
-          <a:ln w="19050">
-            <a:solidFill>
-              <a:srgbClr val="0F172A"/>
-            </a:solidFill>
-          </a:ln>
-        </p:spPr>
-        <p:style>
-          <a:lnRef idx="1">
-            <a:schemeClr val="accent1"/>
-          </a:lnRef>
-          <a:fillRef idx="3">
-            <a:schemeClr val="accent1"/>
-          </a:fillRef>
-          <a:effectRef idx="2">
-            <a:schemeClr val="accent1"/>
-          </a:effectRef>
-          <a:fontRef idx="minor">
-            <a:schemeClr val="lt1"/>
-          </a:fontRef>
-        </p:style>
-        <p:txBody>
-          <a:bodyPr rtlCol="0" anchor="ctr" wrap="square"/>
-          <a:lstStyle/>
-          <a:p>
-            <a:pPr algn="ctr">
-              <a:defRPr sz="900" b="1">
-                <a:solidFill>
-                  <a:srgbClr val="0F172A"/>
-                </a:solidFill>
-                <a:latin typeface="Calibri"/>
-              </a:defRPr>
-            </a:pPr>
-            <a:r>
-              <a:t>  🗣️ Aarti Singh &amp; Yash Sanikop  |  DevOps &amp; AI Leads</a:t>
             </a:r>
           </a:p>
         </p:txBody>
@@ -9713,6 +9273,7 @@
           <a:lstStyle/>
           <a:p>
             <a:pPr algn="ctr"/>
+            <a:endParaRPr/>
           </a:p>
         </p:txBody>
       </p:sp>
@@ -9761,7 +9322,7 @@
         <p:spPr>
           <a:xfrm>
             <a:off x="731520" y="6510528"/>
-            <a:ext cx="8686800" cy="274320"/>
+            <a:ext cx="4692310" cy="233782"/>
           </a:xfrm>
           <a:prstGeom prst="rect">
             <a:avLst/>
@@ -9783,7 +9344,12 @@
               </a:defRPr>
             </a:pPr>
             <a:r>
-              <a:t>SupportSense AI — Developer-to-Developer Client Pitch | Persistent Systems Internship | Yash Sanikop (23CO76)</a:t>
+              <a:rPr dirty="0" err="1"/>
+              <a:t>SupportSense</a:t>
+            </a:r>
+            <a:r>
+              <a:rPr dirty="0"/>
+              <a:t> AI — Developer-to-Developer Client Pitch | Persistent Systems Internship | </a:t>
             </a:r>
           </a:p>
         </p:txBody>
@@ -9830,6 +9396,7 @@
           <a:lstStyle/>
           <a:p>
             <a:pPr algn="ctr"/>
+            <a:endParaRPr/>
           </a:p>
         </p:txBody>
       </p:sp>
@@ -10072,6 +9639,7 @@
           <a:lstStyle/>
           <a:p>
             <a:pPr algn="ctr"/>
+            <a:endParaRPr/>
           </a:p>
         </p:txBody>
       </p:sp>
@@ -10166,6 +9734,7 @@
           <a:lstStyle/>
           <a:p>
             <a:pPr algn="ctr"/>
+            <a:endParaRPr/>
           </a:p>
         </p:txBody>
       </p:sp>
@@ -10178,7 +9747,7 @@
           <p:nvPr/>
         </p:nvPicPr>
         <p:blipFill>
-          <a:blip r:embed="rId2"/>
+          <a:blip r:embed="rId3"/>
           <a:stretch>
             <a:fillRect/>
           </a:stretch>
@@ -10311,7 +9880,7 @@
 </file>
 
 <file path=ppt/slides/slide8.xml><?xml version="1.0" encoding="utf-8"?>
-<p:sld xmlns:a="http://schemas.openxmlformats.org/drawingml/2006/main" xmlns:p="http://schemas.openxmlformats.org/presentationml/2006/main" xmlns:r="http://schemas.openxmlformats.org/officeDocument/2006/relationships">
+<p:sld xmlns:a="http://schemas.openxmlformats.org/drawingml/2006/main" xmlns:r="http://schemas.openxmlformats.org/officeDocument/2006/relationships" xmlns:p="http://schemas.openxmlformats.org/presentationml/2006/main">
   <p:cSld>
     <p:spTree>
       <p:nvGrpSpPr>
@@ -10319,7 +9888,14 @@
         <p:cNvGrpSpPr/>
         <p:nvPr/>
       </p:nvGrpSpPr>
-      <p:grpSpPr/>
+      <p:grpSpPr>
+        <a:xfrm>
+          <a:off x="0" y="0"/>
+          <a:ext cx="0" cy="0"/>
+          <a:chOff x="0" y="0"/>
+          <a:chExt cx="0" cy="0"/>
+        </a:xfrm>
+      </p:grpSpPr>
       <p:sp>
         <p:nvSpPr>
           <p:cNvPr id="2" name="Rectangle 1"/>
@@ -10360,6 +9936,7 @@
           <a:lstStyle/>
           <a:p>
             <a:pPr algn="ctr"/>
+            <a:endParaRPr/>
           </a:p>
         </p:txBody>
       </p:sp>
@@ -10401,7 +9978,7 @@
           </a:fontRef>
         </p:style>
         <p:txBody>
-          <a:bodyPr rtlCol="0" anchor="ctr" wrap="square"/>
+          <a:bodyPr wrap="square" rtlCol="0" anchor="ctr"/>
           <a:lstStyle/>
           <a:p>
             <a:pPr algn="ctr">
@@ -10414,61 +9991,6 @@
             </a:pPr>
             <a:r>
               <a:t>  BUSINESS IMPACT &amp; ROI</a:t>
-            </a:r>
-          </a:p>
-        </p:txBody>
-      </p:sp>
-      <p:sp>
-        <p:nvSpPr>
-          <p:cNvPr id="4" name="Rounded Rectangle 3"/>
-          <p:cNvSpPr/>
-          <p:nvPr/>
-        </p:nvSpPr>
-        <p:spPr>
-          <a:xfrm>
-            <a:off x="7619695" y="365760"/>
-            <a:ext cx="3840480" cy="292608"/>
-          </a:xfrm>
-          <a:prstGeom prst="roundRect">
-            <a:avLst/>
-          </a:prstGeom>
-          <a:solidFill>
-            <a:srgbClr val="FFFFFF"/>
-          </a:solidFill>
-          <a:ln w="19050">
-            <a:solidFill>
-              <a:srgbClr val="0F172A"/>
-            </a:solidFill>
-          </a:ln>
-        </p:spPr>
-        <p:style>
-          <a:lnRef idx="1">
-            <a:schemeClr val="accent1"/>
-          </a:lnRef>
-          <a:fillRef idx="3">
-            <a:schemeClr val="accent1"/>
-          </a:fillRef>
-          <a:effectRef idx="2">
-            <a:schemeClr val="accent1"/>
-          </a:effectRef>
-          <a:fontRef idx="minor">
-            <a:schemeClr val="lt1"/>
-          </a:fontRef>
-        </p:style>
-        <p:txBody>
-          <a:bodyPr rtlCol="0" anchor="ctr" wrap="square"/>
-          <a:lstStyle/>
-          <a:p>
-            <a:pPr algn="ctr">
-              <a:defRPr sz="900" b="1">
-                <a:solidFill>
-                  <a:srgbClr val="0F172A"/>
-                </a:solidFill>
-                <a:latin typeface="Calibri"/>
-              </a:defRPr>
-            </a:pPr>
-            <a:r>
-              <a:t>  🗣️ Joint Team  |  Executive Handover</a:t>
             </a:r>
           </a:p>
         </p:txBody>
@@ -10504,6 +10026,7 @@
               </a:defRPr>
             </a:pPr>
             <a:r>
+              <a:rPr dirty="0"/>
               <a:t>Business Impact Metrics &amp; Client ROI Handover</a:t>
             </a:r>
           </a:p>
@@ -10585,6 +10108,7 @@
           <a:lstStyle/>
           <a:p>
             <a:pPr algn="ctr"/>
+            <a:endParaRPr/>
           </a:p>
         </p:txBody>
       </p:sp>
@@ -10633,7 +10157,7 @@
         <p:spPr>
           <a:xfrm>
             <a:off x="731520" y="6510528"/>
-            <a:ext cx="8686800" cy="274320"/>
+            <a:ext cx="4692310" cy="233782"/>
           </a:xfrm>
           <a:prstGeom prst="rect">
             <a:avLst/>
@@ -10655,7 +10179,12 @@
               </a:defRPr>
             </a:pPr>
             <a:r>
-              <a:t>SupportSense AI — Developer-to-Developer Client Pitch | Persistent Systems Internship | Yash Sanikop (23CO76)</a:t>
+              <a:rPr dirty="0" err="1"/>
+              <a:t>SupportSense</a:t>
+            </a:r>
+            <a:r>
+              <a:rPr dirty="0"/>
+              <a:t> AI — Developer-to-Developer Client Pitch | Persistent Systems Internship | </a:t>
             </a:r>
           </a:p>
         </p:txBody>
@@ -10702,6 +10231,7 @@
           <a:lstStyle/>
           <a:p>
             <a:pPr algn="ctr"/>
+            <a:endParaRPr/>
           </a:p>
         </p:txBody>
       </p:sp>
@@ -10815,6 +10345,7 @@
           <a:lstStyle/>
           <a:p>
             <a:pPr algn="ctr"/>
+            <a:endParaRPr/>
           </a:p>
         </p:txBody>
       </p:sp>
@@ -10928,6 +10459,7 @@
           <a:lstStyle/>
           <a:p>
             <a:pPr algn="ctr"/>
+            <a:endParaRPr/>
           </a:p>
         </p:txBody>
       </p:sp>
@@ -11041,6 +10573,7 @@
           <a:lstStyle/>
           <a:p>
             <a:pPr algn="ctr"/>
+            <a:endParaRPr/>
           </a:p>
         </p:txBody>
       </p:sp>
@@ -11154,6 +10687,7 @@
           <a:lstStyle/>
           <a:p>
             <a:pPr algn="ctr"/>
+            <a:endParaRPr/>
           </a:p>
         </p:txBody>
       </p:sp>
@@ -11371,6 +10905,7 @@
           <a:lstStyle/>
           <a:p>
             <a:pPr algn="ctr"/>
+            <a:endParaRPr/>
           </a:p>
         </p:txBody>
       </p:sp>
@@ -11465,6 +11000,7 @@
           <a:lstStyle/>
           <a:p>
             <a:pPr algn="ctr"/>
+            <a:endParaRPr/>
           </a:p>
         </p:txBody>
       </p:sp>
@@ -11477,7 +11013,7 @@
           <p:nvPr/>
         </p:nvPicPr>
         <p:blipFill>
-          <a:blip r:embed="rId2"/>
+          <a:blip r:embed="rId3"/>
           <a:stretch>
             <a:fillRect/>
           </a:stretch>
@@ -11867,44 +11403,44 @@
         <a:sysClr val="window" lastClr="FFFFFF"/>
       </a:lt1>
       <a:dk2>
-        <a:srgbClr val="1F497D"/>
+        <a:srgbClr val="44546A"/>
       </a:dk2>
       <a:lt2>
-        <a:srgbClr val="EEECE1"/>
+        <a:srgbClr val="E7E6E6"/>
       </a:lt2>
       <a:accent1>
-        <a:srgbClr val="4F81BD"/>
+        <a:srgbClr val="4472C4"/>
       </a:accent1>
       <a:accent2>
-        <a:srgbClr val="C0504D"/>
+        <a:srgbClr val="ED7D31"/>
       </a:accent2>
       <a:accent3>
-        <a:srgbClr val="9BBB59"/>
+        <a:srgbClr val="A5A5A5"/>
       </a:accent3>
       <a:accent4>
-        <a:srgbClr val="8064A2"/>
+        <a:srgbClr val="FFC000"/>
       </a:accent4>
       <a:accent5>
-        <a:srgbClr val="4BACC6"/>
+        <a:srgbClr val="5B9BD5"/>
       </a:accent5>
       <a:accent6>
-        <a:srgbClr val="F79646"/>
+        <a:srgbClr val="70AD47"/>
       </a:accent6>
       <a:hlink>
-        <a:srgbClr val="0000FF"/>
+        <a:srgbClr val="0563C1"/>
       </a:hlink>
       <a:folHlink>
-        <a:srgbClr val="800080"/>
+        <a:srgbClr val="954F72"/>
       </a:folHlink>
     </a:clrScheme>
     <a:fontScheme name="Office">
       <a:majorFont>
-        <a:latin typeface="Calibri"/>
+        <a:latin typeface="Calibri Light" panose="020F0302020204030204"/>
         <a:ea typeface=""/>
         <a:cs typeface=""/>
-        <a:font script="Jpan" typeface="ＭＳ Ｐゴシック"/>
+        <a:font script="Jpan" typeface="游ゴシック Light"/>
         <a:font script="Hang" typeface="맑은 고딕"/>
-        <a:font script="Hans" typeface="宋体"/>
+        <a:font script="Hans" typeface="等线 Light"/>
         <a:font script="Hant" typeface="新細明體"/>
         <a:font script="Arab" typeface="Times New Roman"/>
         <a:font script="Hebr" typeface="Times New Roman"/>
@@ -11932,14 +11468,31 @@
         <a:font script="Viet" typeface="Times New Roman"/>
         <a:font script="Uigh" typeface="Microsoft Uighur"/>
         <a:font script="Geor" typeface="Sylfaen"/>
+        <a:font script="Armn" typeface="Arial"/>
+        <a:font script="Bugi" typeface="Leelawadee UI"/>
+        <a:font script="Bopo" typeface="Microsoft JhengHei"/>
+        <a:font script="Java" typeface="Javanese Text"/>
+        <a:font script="Lisu" typeface="Segoe UI"/>
+        <a:font script="Mymr" typeface="Myanmar Text"/>
+        <a:font script="Nkoo" typeface="Ebrima"/>
+        <a:font script="Olck" typeface="Nirmala UI"/>
+        <a:font script="Osma" typeface="Ebrima"/>
+        <a:font script="Phag" typeface="Phagspa"/>
+        <a:font script="Syrn" typeface="Estrangelo Edessa"/>
+        <a:font script="Syrj" typeface="Estrangelo Edessa"/>
+        <a:font script="Syre" typeface="Estrangelo Edessa"/>
+        <a:font script="Sora" typeface="Nirmala UI"/>
+        <a:font script="Tale" typeface="Microsoft Tai Le"/>
+        <a:font script="Talu" typeface="Microsoft New Tai Lue"/>
+        <a:font script="Tfng" typeface="Ebrima"/>
       </a:majorFont>
       <a:minorFont>
-        <a:latin typeface="Calibri"/>
+        <a:latin typeface="Calibri" panose="020F0502020204030204"/>
         <a:ea typeface=""/>
         <a:cs typeface=""/>
-        <a:font script="Jpan" typeface="ＭＳ Ｐゴシック"/>
+        <a:font script="Jpan" typeface="游ゴシック"/>
         <a:font script="Hang" typeface="맑은 고딕"/>
-        <a:font script="Hans" typeface="宋体"/>
+        <a:font script="Hans" typeface="等线"/>
         <a:font script="Hant" typeface="新細明體"/>
         <a:font script="Arab" typeface="Arial"/>
         <a:font script="Hebr" typeface="Arial"/>
@@ -11967,6 +11520,23 @@
         <a:font script="Viet" typeface="Arial"/>
         <a:font script="Uigh" typeface="Microsoft Uighur"/>
         <a:font script="Geor" typeface="Sylfaen"/>
+        <a:font script="Armn" typeface="Arial"/>
+        <a:font script="Bugi" typeface="Leelawadee UI"/>
+        <a:font script="Bopo" typeface="Microsoft JhengHei"/>
+        <a:font script="Java" typeface="Javanese Text"/>
+        <a:font script="Lisu" typeface="Segoe UI"/>
+        <a:font script="Mymr" typeface="Myanmar Text"/>
+        <a:font script="Nkoo" typeface="Ebrima"/>
+        <a:font script="Olck" typeface="Nirmala UI"/>
+        <a:font script="Osma" typeface="Ebrima"/>
+        <a:font script="Phag" typeface="Phagspa"/>
+        <a:font script="Syrn" typeface="Estrangelo Edessa"/>
+        <a:font script="Syrj" typeface="Estrangelo Edessa"/>
+        <a:font script="Syre" typeface="Estrangelo Edessa"/>
+        <a:font script="Sora" typeface="Nirmala UI"/>
+        <a:font script="Tale" typeface="Microsoft Tai Le"/>
+        <a:font script="Talu" typeface="Microsoft New Tai Lue"/>
+        <a:font script="Tfng" typeface="Ebrima"/>
       </a:minorFont>
     </a:fontScheme>
     <a:fmtScheme name="Office">
@@ -11978,200 +11548,141 @@
           <a:gsLst>
             <a:gs pos="0">
               <a:schemeClr val="phClr">
-                <a:tint val="50000"/>
-                <a:satMod val="300000"/>
+                <a:lumMod val="110000"/>
+                <a:satMod val="105000"/>
+                <a:tint val="67000"/>
               </a:schemeClr>
             </a:gs>
-            <a:gs pos="35000">
+            <a:gs pos="50000">
               <a:schemeClr val="phClr">
-                <a:tint val="37000"/>
-                <a:satMod val="300000"/>
+                <a:lumMod val="105000"/>
+                <a:satMod val="103000"/>
+                <a:tint val="73000"/>
               </a:schemeClr>
             </a:gs>
             <a:gs pos="100000">
               <a:schemeClr val="phClr">
-                <a:tint val="15000"/>
-                <a:satMod val="350000"/>
+                <a:lumMod val="105000"/>
+                <a:satMod val="109000"/>
+                <a:tint val="81000"/>
               </a:schemeClr>
             </a:gs>
           </a:gsLst>
-          <a:lin ang="16200000" scaled="1"/>
+          <a:lin ang="5400000" scaled="0"/>
         </a:gradFill>
         <a:gradFill rotWithShape="1">
           <a:gsLst>
             <a:gs pos="0">
               <a:schemeClr val="phClr">
-                <a:tint val="100000"/>
+                <a:satMod val="103000"/>
+                <a:lumMod val="102000"/>
+                <a:tint val="94000"/>
+              </a:schemeClr>
+            </a:gs>
+            <a:gs pos="50000">
+              <a:schemeClr val="phClr">
+                <a:satMod val="110000"/>
+                <a:lumMod val="100000"/>
                 <a:shade val="100000"/>
-                <a:satMod val="130000"/>
               </a:schemeClr>
             </a:gs>
             <a:gs pos="100000">
               <a:schemeClr val="phClr">
-                <a:tint val="50000"/>
-                <a:shade val="100000"/>
-                <a:satMod val="350000"/>
+                <a:lumMod val="99000"/>
+                <a:satMod val="120000"/>
+                <a:shade val="78000"/>
               </a:schemeClr>
             </a:gs>
           </a:gsLst>
-          <a:lin ang="16200000" scaled="0"/>
+          <a:lin ang="5400000" scaled="0"/>
         </a:gradFill>
       </a:fillStyleLst>
       <a:lnStyleLst>
-        <a:ln w="9525" cap="flat" cmpd="sng" algn="ctr">
-          <a:solidFill>
-            <a:schemeClr val="phClr">
-              <a:shade val="95000"/>
-              <a:satMod val="105000"/>
-            </a:schemeClr>
-          </a:solidFill>
-          <a:prstDash val="solid"/>
-        </a:ln>
-        <a:ln w="25400" cap="flat" cmpd="sng" algn="ctr">
+        <a:ln w="6350" cap="flat" cmpd="sng" algn="ctr">
           <a:solidFill>
             <a:schemeClr val="phClr"/>
           </a:solidFill>
           <a:prstDash val="solid"/>
+          <a:miter lim="800000"/>
         </a:ln>
-        <a:ln w="38100" cap="flat" cmpd="sng" algn="ctr">
+        <a:ln w="12700" cap="flat" cmpd="sng" algn="ctr">
           <a:solidFill>
             <a:schemeClr val="phClr"/>
           </a:solidFill>
           <a:prstDash val="solid"/>
+          <a:miter lim="800000"/>
+        </a:ln>
+        <a:ln w="19050" cap="flat" cmpd="sng" algn="ctr">
+          <a:solidFill>
+            <a:schemeClr val="phClr"/>
+          </a:solidFill>
+          <a:prstDash val="solid"/>
+          <a:miter lim="800000"/>
         </a:ln>
       </a:lnStyleLst>
       <a:effectStyleLst>
         <a:effectStyle>
+          <a:effectLst/>
+        </a:effectStyle>
+        <a:effectStyle>
+          <a:effectLst/>
+        </a:effectStyle>
+        <a:effectStyle>
           <a:effectLst>
-            <a:outerShdw blurRad="40000" dist="20000" dir="5400000" rotWithShape="0">
+            <a:outerShdw blurRad="57150" dist="19050" dir="5400000" algn="ctr" rotWithShape="0">
               <a:srgbClr val="000000">
-                <a:alpha val="38000"/>
+                <a:alpha val="63000"/>
               </a:srgbClr>
             </a:outerShdw>
           </a:effectLst>
-        </a:effectStyle>
-        <a:effectStyle>
-          <a:effectLst>
-            <a:outerShdw blurRad="40000" dist="23000" dir="5400000" rotWithShape="0">
-              <a:srgbClr val="000000">
-                <a:alpha val="35000"/>
-              </a:srgbClr>
-            </a:outerShdw>
-          </a:effectLst>
-        </a:effectStyle>
-        <a:effectStyle>
-          <a:effectLst>
-            <a:outerShdw blurRad="40000" dist="23000" dir="5400000" rotWithShape="0">
-              <a:srgbClr val="000000">
-                <a:alpha val="35000"/>
-              </a:srgbClr>
-            </a:outerShdw>
-          </a:effectLst>
-          <a:scene3d>
-            <a:camera prst="orthographicFront">
-              <a:rot lat="0" lon="0" rev="0"/>
-            </a:camera>
-            <a:lightRig rig="threePt" dir="t">
-              <a:rot lat="0" lon="0" rev="1200000"/>
-            </a:lightRig>
-          </a:scene3d>
-          <a:sp3d>
-            <a:bevelT w="63500" h="25400"/>
-          </a:sp3d>
         </a:effectStyle>
       </a:effectStyleLst>
       <a:bgFillStyleLst>
         <a:solidFill>
           <a:schemeClr val="phClr"/>
         </a:solidFill>
+        <a:solidFill>
+          <a:schemeClr val="phClr">
+            <a:tint val="95000"/>
+            <a:satMod val="170000"/>
+          </a:schemeClr>
+        </a:solidFill>
         <a:gradFill rotWithShape="1">
           <a:gsLst>
             <a:gs pos="0">
               <a:schemeClr val="phClr">
-                <a:tint val="40000"/>
-                <a:satMod val="350000"/>
+                <a:tint val="93000"/>
+                <a:satMod val="150000"/>
+                <a:shade val="98000"/>
+                <a:lumMod val="102000"/>
               </a:schemeClr>
             </a:gs>
-            <a:gs pos="40000">
+            <a:gs pos="50000">
               <a:schemeClr val="phClr">
-                <a:tint val="45000"/>
-                <a:shade val="99000"/>
-                <a:satMod val="350000"/>
+                <a:tint val="98000"/>
+                <a:satMod val="130000"/>
+                <a:shade val="90000"/>
+                <a:lumMod val="103000"/>
               </a:schemeClr>
             </a:gs>
             <a:gs pos="100000">
               <a:schemeClr val="phClr">
-                <a:shade val="20000"/>
-                <a:satMod val="255000"/>
+                <a:shade val="63000"/>
+                <a:satMod val="120000"/>
               </a:schemeClr>
             </a:gs>
           </a:gsLst>
-          <a:path path="circle">
-            <a:fillToRect l="50000" t="-80000" r="50000" b="180000"/>
-          </a:path>
-        </a:gradFill>
-        <a:gradFill rotWithShape="1">
-          <a:gsLst>
-            <a:gs pos="0">
-              <a:schemeClr val="phClr">
-                <a:tint val="80000"/>
-                <a:satMod val="300000"/>
-              </a:schemeClr>
-            </a:gs>
-            <a:gs pos="100000">
-              <a:schemeClr val="phClr">
-                <a:shade val="30000"/>
-                <a:satMod val="200000"/>
-              </a:schemeClr>
-            </a:gs>
-          </a:gsLst>
-          <a:path path="circle">
-            <a:fillToRect l="50000" t="50000" r="50000" b="50000"/>
-          </a:path>
+          <a:lin ang="5400000" scaled="0"/>
         </a:gradFill>
       </a:bgFillStyleLst>
     </a:fmtScheme>
   </a:themeElements>
-  <a:objectDefaults>
-    <a:spDef>
-      <a:spPr/>
-      <a:bodyPr/>
-      <a:lstStyle/>
-      <a:style>
-        <a:lnRef idx="1">
-          <a:schemeClr val="accent1"/>
-        </a:lnRef>
-        <a:fillRef idx="3">
-          <a:schemeClr val="accent1"/>
-        </a:fillRef>
-        <a:effectRef idx="2">
-          <a:schemeClr val="accent1"/>
-        </a:effectRef>
-        <a:fontRef idx="minor">
-          <a:schemeClr val="lt1"/>
-        </a:fontRef>
-      </a:style>
-    </a:spDef>
-    <a:lnDef>
-      <a:spPr/>
-      <a:bodyPr/>
-      <a:lstStyle/>
-      <a:style>
-        <a:lnRef idx="2">
-          <a:schemeClr val="accent1"/>
-        </a:lnRef>
-        <a:fillRef idx="0">
-          <a:schemeClr val="accent1"/>
-        </a:fillRef>
-        <a:effectRef idx="1">
-          <a:schemeClr val="accent1"/>
-        </a:effectRef>
-        <a:fontRef idx="minor">
-          <a:schemeClr val="tx1"/>
-        </a:fontRef>
-      </a:style>
-    </a:lnDef>
-  </a:objectDefaults>
+  <a:objectDefaults/>
   <a:extraClrSchemeLst/>
+  <a:extLst>
+    <a:ext uri="{05A4C25C-085E-4340-85A3-A5531E510DB2}">
+      <thm15:themeFamily xmlns:thm15="http://schemas.microsoft.com/office/thememl/2012/main" name="Office Theme" id="{62F939B6-93AF-4DB8-9C6B-D6C7DFDC589F}" vid="{4A3C46E8-61CC-4603-A589-7422A47A8E4A}"/>
+    </a:ext>
+  </a:extLst>
 </a:theme>
 </file>
</xml_diff>